<commit_message>
v7: swimlane — clarify setup steps are order-independent
The left-to-right lanes wrongly implied you must Analyse the statements
before setting mandate/risk/allocations. In fact the whole Intake page
works with no book: statement ingest (Step 1) and policy setup (Steps
2-3) are independent — any order — and only the review/proposal views
need a parsed book. Reworded the answer callout ("And the order?"),
box 1 ("any time · independent of 2-3"), and the footer key point in
both the HTML artifact and the native PPTX (slide-1 navy band + slide-2
footer). HTML republished to the same URL; PPTX regenerated and
re-rendered via LibreOffice (both slides verified).

Co-Authored-By: Claude Opus 4.8 <noreply@anthropic.com>
</commit_message>
<xml_diff>
--- a/Tactical_Swimlane.pptx
+++ b/Tactical_Swimlane.pptx
@@ -3512,8 +3512,8 @@
         </p:nvSpPr>
         <p:spPr>
           <a:xfrm>
-            <a:off x="731520" y="6144768"/>
-            <a:ext cx="10725912" cy="658368"/>
+            <a:off x="731520" y="5989320"/>
+            <a:ext cx="10725912" cy="804672"/>
           </a:xfrm>
           <a:prstGeom prst="roundRect">
             <a:avLst>
@@ -3548,7 +3548,7 @@
           <a:p>
             <a:pPr algn="l">
               <a:lnSpc>
-                <a:spcPct val="100000"/>
+                <a:spcPct val="106000"/>
               </a:lnSpc>
               <a:spcBef>
                 <a:spcPts val="0"/>
@@ -3558,22 +3558,22 @@
               </a:spcAft>
             </a:pPr>
             <a:r>
-              <a:rPr sz="1250" b="1">
+              <a:rPr sz="1200" b="1">
                 <a:solidFill>
                   <a:srgbClr val="B0872A"/>
                 </a:solidFill>
                 <a:latin typeface="Calibri"/>
               </a:rPr>
-              <a:t>And Analyse?  </a:t>
-            </a:r>
-            <a:r>
-              <a:rPr sz="1250" b="0">
+              <a:t>Order &amp; Analyse:  </a:t>
+            </a:r>
+            <a:r>
+              <a:rPr sz="1200" b="0">
                 <a:solidFill>
                   <a:srgbClr val="FFFFFF"/>
                 </a:solidFill>
                 <a:latin typeface="Calibri"/>
               </a:rPr>
-              <a:t>It processes the client’s statements. After Confirm, every view updates live — you don’t press Analyse again.</a:t>
+              <a:t>Loading the statements and setting the mandate / risk / allocations are independent — do them in any order. Analyse processes the statements; after Confirm the views update live (no re-Analyse).</a:t>
             </a:r>
           </a:p>
         </p:txBody>
@@ -4702,7 +4702,7 @@
                 </a:solidFill>
                 <a:latin typeface="Calibri"/>
               </a:rPr>
-              <a:t>ingest the statements</a:t>
+              <a:t>any time · independent of 2–3</a:t>
             </a:r>
           </a:p>
         </p:txBody>
@@ -6033,7 +6033,7 @@
                 </a:solidFill>
                 <a:latin typeface="Calibri"/>
               </a:rPr>
-              <a:t>Key point: Confirm (6) fills no fields — allocation sleeves are written only via Apply (7); limits are always manual.</a:t>
+              <a:t>Key point: setup (1–7) is any-order; Confirm (6) fills no fields; allocations only via Apply (7); limits always manual.</a:t>
             </a:r>
           </a:p>
         </p:txBody>

</xml_diff>

<commit_message>
v7: reorder swimlane to policy-first, Analyse-after
Per product decision: Analyse should be pressed only after the mandate,
risk and allocations are set — analysing first computes against the default
preset and confuses users. Reordered phases to A Set profile & policy,
B Capture tactical instructions, C Analyse, D Review & generate, and
renumbered boxes (Confirm 5, Apply 6, Analyse 7). Updated HTML note, PPTX
generator (both slides) and regenerated the deck.

Co-Authored-By: Claude Opus 4.8 <noreply@anthropic.com>
</commit_message>
<xml_diff>
--- a/Tactical_Swimlane.pptx
+++ b/Tactical_Swimlane.pptx
@@ -3573,7 +3573,7 @@
                 </a:solidFill>
                 <a:latin typeface="Calibri"/>
               </a:rPr>
-              <a:t>Loading the statements and setting the mandate / risk / allocations are independent — do them in any order. Analyse processes the statements; after Confirm the views update live (no re-Analyse).</a:t>
+              <a:t>Set the mandate / risk / allocations first, then press Analyse — so the first analysis already reflects the client's policy (analysing first computes against the default preset). After Confirm the views update live; no re-Analyse.</a:t>
             </a:r>
           </a:p>
         </p:txBody>
@@ -3745,6 +3745,154 @@
         <p:spPr>
           <a:xfrm>
             <a:off x="1234440" y="1371600"/>
+            <a:ext cx="2286000" cy="347472"/>
+          </a:xfrm>
+          <a:prstGeom prst="roundRect">
+            <a:avLst>
+              <a:gd name="adj" fmla="val 4000"/>
+            </a:avLst>
+          </a:prstGeom>
+          <a:solidFill>
+            <a:srgbClr val="131D3D"/>
+          </a:solidFill>
+          <a:ln>
+            <a:noFill/>
+          </a:ln>
+          <a:effectLst/>
+        </p:spPr>
+        <p:style>
+          <a:lnRef idx="1">
+            <a:schemeClr val="accent1"/>
+          </a:lnRef>
+          <a:fillRef idx="3">
+            <a:schemeClr val="accent1"/>
+          </a:fillRef>
+          <a:effectRef idx="2">
+            <a:schemeClr val="accent1"/>
+          </a:effectRef>
+          <a:fontRef idx="minor">
+            <a:schemeClr val="lt1"/>
+          </a:fontRef>
+        </p:style>
+        <p:txBody>
+          <a:bodyPr rtlCol="0" anchor="ctr" wrap="square" lIns="73152" rIns="64008"/>
+          <a:lstStyle/>
+          <a:p>
+            <a:pPr algn="ctr">
+              <a:lnSpc>
+                <a:spcPct val="100000"/>
+              </a:lnSpc>
+              <a:spcBef>
+                <a:spcPts val="0"/>
+              </a:spcBef>
+              <a:spcAft>
+                <a:spcPts val="0"/>
+              </a:spcAft>
+            </a:pPr>
+            <a:r>
+              <a:rPr sz="1100" b="1">
+                <a:solidFill>
+                  <a:srgbClr val="B0872A"/>
+                </a:solidFill>
+                <a:latin typeface="Consolas"/>
+              </a:rPr>
+              <a:t>A  </a:t>
+            </a:r>
+            <a:r>
+              <a:rPr sz="1150" b="1">
+                <a:solidFill>
+                  <a:srgbClr val="FFFFFF"/>
+                </a:solidFill>
+                <a:latin typeface="Calibri"/>
+              </a:rPr>
+              <a:t>Set profile &amp; policy</a:t>
+            </a:r>
+          </a:p>
+        </p:txBody>
+      </p:sp>
+      <p:sp>
+        <p:nvSpPr>
+          <p:cNvPr id="6" name="Rounded Rectangle 5"/>
+          <p:cNvSpPr/>
+          <p:nvPr/>
+        </p:nvSpPr>
+        <p:spPr>
+          <a:xfrm>
+            <a:off x="3520440" y="1371600"/>
+            <a:ext cx="4261104" cy="347472"/>
+          </a:xfrm>
+          <a:prstGeom prst="roundRect">
+            <a:avLst>
+              <a:gd name="adj" fmla="val 4000"/>
+            </a:avLst>
+          </a:prstGeom>
+          <a:solidFill>
+            <a:srgbClr val="131D3D"/>
+          </a:solidFill>
+          <a:ln>
+            <a:noFill/>
+          </a:ln>
+          <a:effectLst/>
+        </p:spPr>
+        <p:style>
+          <a:lnRef idx="1">
+            <a:schemeClr val="accent1"/>
+          </a:lnRef>
+          <a:fillRef idx="3">
+            <a:schemeClr val="accent1"/>
+          </a:fillRef>
+          <a:effectRef idx="2">
+            <a:schemeClr val="accent1"/>
+          </a:effectRef>
+          <a:fontRef idx="minor">
+            <a:schemeClr val="lt1"/>
+          </a:fontRef>
+        </p:style>
+        <p:txBody>
+          <a:bodyPr rtlCol="0" anchor="ctr" wrap="square" lIns="73152" rIns="64008"/>
+          <a:lstStyle/>
+          <a:p>
+            <a:pPr algn="ctr">
+              <a:lnSpc>
+                <a:spcPct val="100000"/>
+              </a:lnSpc>
+              <a:spcBef>
+                <a:spcPts val="0"/>
+              </a:spcBef>
+              <a:spcAft>
+                <a:spcPts val="0"/>
+              </a:spcAft>
+            </a:pPr>
+            <a:r>
+              <a:rPr sz="1100" b="1">
+                <a:solidFill>
+                  <a:srgbClr val="B0872A"/>
+                </a:solidFill>
+                <a:latin typeface="Consolas"/>
+              </a:rPr>
+              <a:t>B  </a:t>
+            </a:r>
+            <a:r>
+              <a:rPr sz="1150" b="1">
+                <a:solidFill>
+                  <a:srgbClr val="FFFFFF"/>
+                </a:solidFill>
+                <a:latin typeface="Calibri"/>
+              </a:rPr>
+              <a:t>Capture tactical instructions</a:t>
+            </a:r>
+          </a:p>
+        </p:txBody>
+      </p:sp>
+      <p:sp>
+        <p:nvSpPr>
+          <p:cNvPr id="7" name="Rounded Rectangle 6"/>
+          <p:cNvSpPr/>
+          <p:nvPr/>
+        </p:nvSpPr>
+        <p:spPr>
+          <a:xfrm>
+            <a:off x="7781544" y="1371600"/>
             <a:ext cx="1847088" cy="347472"/>
           </a:xfrm>
           <a:prstGeom prst="roundRect">
@@ -3796,7 +3944,7 @@
                 </a:solidFill>
                 <a:latin typeface="Consolas"/>
               </a:rPr>
-              <a:t>A  </a:t>
+              <a:t>C  </a:t>
             </a:r>
             <a:r>
               <a:rPr sz="1150" b="1">
@@ -3805,155 +3953,7 @@
                 </a:solidFill>
                 <a:latin typeface="Calibri"/>
               </a:rPr>
-              <a:t>Ingest</a:t>
-            </a:r>
-          </a:p>
-        </p:txBody>
-      </p:sp>
-      <p:sp>
-        <p:nvSpPr>
-          <p:cNvPr id="6" name="Rounded Rectangle 5"/>
-          <p:cNvSpPr/>
-          <p:nvPr/>
-        </p:nvSpPr>
-        <p:spPr>
-          <a:xfrm>
-            <a:off x="3081528" y="1371600"/>
-            <a:ext cx="2286000" cy="347472"/>
-          </a:xfrm>
-          <a:prstGeom prst="roundRect">
-            <a:avLst>
-              <a:gd name="adj" fmla="val 4000"/>
-            </a:avLst>
-          </a:prstGeom>
-          <a:solidFill>
-            <a:srgbClr val="131D3D"/>
-          </a:solidFill>
-          <a:ln>
-            <a:noFill/>
-          </a:ln>
-          <a:effectLst/>
-        </p:spPr>
-        <p:style>
-          <a:lnRef idx="1">
-            <a:schemeClr val="accent1"/>
-          </a:lnRef>
-          <a:fillRef idx="3">
-            <a:schemeClr val="accent1"/>
-          </a:fillRef>
-          <a:effectRef idx="2">
-            <a:schemeClr val="accent1"/>
-          </a:effectRef>
-          <a:fontRef idx="minor">
-            <a:schemeClr val="lt1"/>
-          </a:fontRef>
-        </p:style>
-        <p:txBody>
-          <a:bodyPr rtlCol="0" anchor="ctr" wrap="square" lIns="73152" rIns="64008"/>
-          <a:lstStyle/>
-          <a:p>
-            <a:pPr algn="ctr">
-              <a:lnSpc>
-                <a:spcPct val="100000"/>
-              </a:lnSpc>
-              <a:spcBef>
-                <a:spcPts val="0"/>
-              </a:spcBef>
-              <a:spcAft>
-                <a:spcPts val="0"/>
-              </a:spcAft>
-            </a:pPr>
-            <a:r>
-              <a:rPr sz="1100" b="1">
-                <a:solidFill>
-                  <a:srgbClr val="B0872A"/>
-                </a:solidFill>
-                <a:latin typeface="Consolas"/>
-              </a:rPr>
-              <a:t>B  </a:t>
-            </a:r>
-            <a:r>
-              <a:rPr sz="1150" b="1">
-                <a:solidFill>
-                  <a:srgbClr val="FFFFFF"/>
-                </a:solidFill>
-                <a:latin typeface="Calibri"/>
-              </a:rPr>
-              <a:t>Mandate &amp; policy</a:t>
-            </a:r>
-          </a:p>
-        </p:txBody>
-      </p:sp>
-      <p:sp>
-        <p:nvSpPr>
-          <p:cNvPr id="7" name="Rounded Rectangle 6"/>
-          <p:cNvSpPr/>
-          <p:nvPr/>
-        </p:nvSpPr>
-        <p:spPr>
-          <a:xfrm>
-            <a:off x="5367528" y="1371600"/>
-            <a:ext cx="4261104" cy="347472"/>
-          </a:xfrm>
-          <a:prstGeom prst="roundRect">
-            <a:avLst>
-              <a:gd name="adj" fmla="val 4000"/>
-            </a:avLst>
-          </a:prstGeom>
-          <a:solidFill>
-            <a:srgbClr val="131D3D"/>
-          </a:solidFill>
-          <a:ln>
-            <a:noFill/>
-          </a:ln>
-          <a:effectLst/>
-        </p:spPr>
-        <p:style>
-          <a:lnRef idx="1">
-            <a:schemeClr val="accent1"/>
-          </a:lnRef>
-          <a:fillRef idx="3">
-            <a:schemeClr val="accent1"/>
-          </a:fillRef>
-          <a:effectRef idx="2">
-            <a:schemeClr val="accent1"/>
-          </a:effectRef>
-          <a:fontRef idx="minor">
-            <a:schemeClr val="lt1"/>
-          </a:fontRef>
-        </p:style>
-        <p:txBody>
-          <a:bodyPr rtlCol="0" anchor="ctr" wrap="square" lIns="73152" rIns="64008"/>
-          <a:lstStyle/>
-          <a:p>
-            <a:pPr algn="ctr">
-              <a:lnSpc>
-                <a:spcPct val="100000"/>
-              </a:lnSpc>
-              <a:spcBef>
-                <a:spcPts val="0"/>
-              </a:spcBef>
-              <a:spcAft>
-                <a:spcPts val="0"/>
-              </a:spcAft>
-            </a:pPr>
-            <a:r>
-              <a:rPr sz="1100" b="1">
-                <a:solidFill>
-                  <a:srgbClr val="B0872A"/>
-                </a:solidFill>
-                <a:latin typeface="Consolas"/>
-              </a:rPr>
-              <a:t>C  </a:t>
-            </a:r>
-            <a:r>
-              <a:rPr sz="1150" b="1">
-                <a:solidFill>
-                  <a:srgbClr val="FFFFFF"/>
-                </a:solidFill>
-                <a:latin typeface="Calibri"/>
-              </a:rPr>
-              <a:t>Capture tactical instructions</a:t>
+              <a:t>Analyse the statements</a:t>
             </a:r>
           </a:p>
         </p:txBody>
@@ -4439,7 +4439,96 @@
         </p:nvSpPr>
         <p:spPr>
           <a:xfrm>
-            <a:off x="1344168" y="1938528"/>
+            <a:off x="3630168" y="1938528"/>
+            <a:ext cx="2556662" cy="713231"/>
+          </a:xfrm>
+          <a:prstGeom prst="roundRect">
+            <a:avLst>
+              <a:gd name="adj" fmla="val 10000"/>
+            </a:avLst>
+          </a:prstGeom>
+          <a:solidFill>
+            <a:srgbClr val="FFFFFF"/>
+          </a:solidFill>
+          <a:ln w="12700">
+            <a:solidFill>
+              <a:srgbClr val="9CA8CE"/>
+            </a:solidFill>
+          </a:ln>
+          <a:effectLst/>
+        </p:spPr>
+        <p:style>
+          <a:lnRef idx="1">
+            <a:schemeClr val="accent1"/>
+          </a:lnRef>
+          <a:fillRef idx="3">
+            <a:schemeClr val="accent1"/>
+          </a:fillRef>
+          <a:effectRef idx="2">
+            <a:schemeClr val="accent1"/>
+          </a:effectRef>
+          <a:fontRef idx="minor">
+            <a:schemeClr val="lt1"/>
+          </a:fontRef>
+        </p:style>
+        <p:txBody>
+          <a:bodyPr rtlCol="0" anchor="ctr" wrap="square" lIns="73152" rIns="64008"/>
+          <a:lstStyle/>
+          <a:p>
+            <a:pPr algn="l">
+              <a:lnSpc>
+                <a:spcPct val="100000"/>
+              </a:lnSpc>
+              <a:spcBef>
+                <a:spcPts val="0"/>
+              </a:spcBef>
+              <a:spcAft>
+                <a:spcPts val="0"/>
+              </a:spcAft>
+            </a:pPr>
+            <a:r>
+              <a:rPr sz="1050" b="1">
+                <a:solidFill>
+                  <a:srgbClr val="16203C"/>
+                </a:solidFill>
+                <a:latin typeface="Calibri"/>
+              </a:rPr>
+              <a:t>Gives instructions (plain language)</a:t>
+            </a:r>
+          </a:p>
+          <a:p>
+            <a:pPr algn="l">
+              <a:lnSpc>
+                <a:spcPct val="102000"/>
+              </a:lnSpc>
+              <a:spcBef>
+                <a:spcPts val="200"/>
+              </a:spcBef>
+              <a:spcAft>
+                <a:spcPts val="0"/>
+              </a:spcAft>
+            </a:pPr>
+            <a:r>
+              <a:rPr sz="800" b="0">
+                <a:solidFill>
+                  <a:srgbClr val="47517A"/>
+                </a:solidFill>
+                <a:latin typeface="Calibri"/>
+              </a:rPr>
+              <a:t>“gold below $4,000”, “Gold ETF: 20%”…</a:t>
+            </a:r>
+          </a:p>
+        </p:txBody>
+      </p:sp>
+      <p:sp>
+        <p:nvSpPr>
+          <p:cNvPr id="16" name="Rounded Rectangle 15"/>
+          <p:cNvSpPr/>
+          <p:nvPr/>
+        </p:nvSpPr>
+        <p:spPr>
+          <a:xfrm>
+            <a:off x="7891271" y="1938528"/>
             <a:ext cx="1627632" cy="713231"/>
           </a:xfrm>
           <a:prstGeom prst="roundRect">
@@ -4522,14 +4611,14 @@
       </p:sp>
       <p:sp>
         <p:nvSpPr>
-          <p:cNvPr id="16" name="Rounded Rectangle 15"/>
+          <p:cNvPr id="17" name="Rounded Rectangle 16"/>
           <p:cNvSpPr/>
           <p:nvPr/>
         </p:nvSpPr>
         <p:spPr>
           <a:xfrm>
-            <a:off x="5477256" y="1938528"/>
-            <a:ext cx="2641884" cy="713231"/>
+            <a:off x="1344168" y="3108960"/>
+            <a:ext cx="2066543" cy="932688"/>
           </a:xfrm>
           <a:prstGeom prst="roundRect">
             <a:avLst>
@@ -4539,9 +4628,9 @@
           <a:solidFill>
             <a:srgbClr val="FFFFFF"/>
           </a:solidFill>
-          <a:ln w="12700">
+          <a:ln w="15875">
             <a:solidFill>
-              <a:srgbClr val="9CA8CE"/>
+              <a:srgbClr val="B0872A"/>
             </a:solidFill>
           </a:ln>
           <a:effectLst/>
@@ -4576,13 +4665,98 @@
               </a:spcAft>
             </a:pPr>
             <a:r>
-              <a:rPr sz="1050" b="1">
+              <a:rPr sz="1000" b="1">
+                <a:solidFill>
+                  <a:srgbClr val="9C7422"/>
+                </a:solidFill>
+                <a:latin typeface="Calibri"/>
+              </a:rPr>
+              <a:t>1 · </a:t>
+            </a:r>
+            <a:r>
+              <a:rPr sz="1000" b="1">
                 <a:solidFill>
                   <a:srgbClr val="16203C"/>
                 </a:solidFill>
                 <a:latin typeface="Calibri"/>
               </a:rPr>
-              <a:t>Gives instructions (plain language)</a:t>
+              <a:t>Set mandate, risk &amp; ability</a:t>
+            </a:r>
+          </a:p>
+        </p:txBody>
+      </p:sp>
+      <p:sp>
+        <p:nvSpPr>
+          <p:cNvPr id="18" name="Rounded Rectangle 17"/>
+          <p:cNvSpPr/>
+          <p:nvPr/>
+        </p:nvSpPr>
+        <p:spPr>
+          <a:xfrm>
+            <a:off x="1344168" y="4114800"/>
+            <a:ext cx="2066543" cy="932688"/>
+          </a:xfrm>
+          <a:prstGeom prst="roundRect">
+            <a:avLst>
+              <a:gd name="adj" fmla="val 10000"/>
+            </a:avLst>
+          </a:prstGeom>
+          <a:solidFill>
+            <a:srgbClr val="FFFFFF"/>
+          </a:solidFill>
+          <a:ln w="15875">
+            <a:solidFill>
+              <a:srgbClr val="B0872A"/>
+            </a:solidFill>
+          </a:ln>
+          <a:effectLst/>
+        </p:spPr>
+        <p:style>
+          <a:lnRef idx="1">
+            <a:schemeClr val="accent1"/>
+          </a:lnRef>
+          <a:fillRef idx="3">
+            <a:schemeClr val="accent1"/>
+          </a:fillRef>
+          <a:effectRef idx="2">
+            <a:schemeClr val="accent1"/>
+          </a:effectRef>
+          <a:fontRef idx="minor">
+            <a:schemeClr val="lt1"/>
+          </a:fontRef>
+        </p:style>
+        <p:txBody>
+          <a:bodyPr rtlCol="0" anchor="ctr" wrap="square" lIns="73152" rIns="64008"/>
+          <a:lstStyle/>
+          <a:p>
+            <a:pPr algn="l">
+              <a:lnSpc>
+                <a:spcPct val="100000"/>
+              </a:lnSpc>
+              <a:spcBef>
+                <a:spcPts val="0"/>
+              </a:spcBef>
+              <a:spcAft>
+                <a:spcPts val="0"/>
+              </a:spcAft>
+            </a:pPr>
+            <a:r>
+              <a:rPr sz="1000" b="1">
+                <a:solidFill>
+                  <a:srgbClr val="9C7422"/>
+                </a:solidFill>
+                <a:latin typeface="Calibri"/>
+              </a:rPr>
+              <a:t>2 · </a:t>
+            </a:r>
+            <a:r>
+              <a:rPr sz="1000" b="1">
+                <a:solidFill>
+                  <a:srgbClr val="16203C"/>
+                </a:solidFill>
+                <a:latin typeface="Calibri"/>
+              </a:rPr>
+              <a:t>Set allocation targets &amp; limits</a:t>
             </a:r>
           </a:p>
           <a:p>
@@ -4598,26 +4772,450 @@
               </a:spcAft>
             </a:pPr>
             <a:r>
-              <a:rPr sz="800" b="0">
+              <a:rPr sz="830" b="0">
                 <a:solidFill>
                   <a:srgbClr val="47517A"/>
                 </a:solidFill>
                 <a:latin typeface="Calibri"/>
               </a:rPr>
-              <a:t>“gold below $4,000”, “buy in tranches”…</a:t>
-            </a:r>
-          </a:p>
-        </p:txBody>
-      </p:sp>
-      <p:sp>
-        <p:nvSpPr>
-          <p:cNvPr id="17" name="Rounded Rectangle 16"/>
+              <a:t>limits manual · sleeves can be pre-filled by 6</a:t>
+            </a:r>
+          </a:p>
+        </p:txBody>
+      </p:sp>
+      <p:sp>
+        <p:nvSpPr>
+          <p:cNvPr id="19" name="Rounded Rectangle 18"/>
           <p:cNvSpPr/>
           <p:nvPr/>
         </p:nvSpPr>
         <p:spPr>
           <a:xfrm>
-            <a:off x="1344168" y="3575304"/>
+            <a:off x="3611880" y="2999232"/>
+            <a:ext cx="1965960" cy="658368"/>
+          </a:xfrm>
+          <a:prstGeom prst="roundRect">
+            <a:avLst>
+              <a:gd name="adj" fmla="val 10000"/>
+            </a:avLst>
+          </a:prstGeom>
+          <a:solidFill>
+            <a:srgbClr val="FFFFFF"/>
+          </a:solidFill>
+          <a:ln w="15875">
+            <a:solidFill>
+              <a:srgbClr val="B0872A"/>
+            </a:solidFill>
+          </a:ln>
+          <a:effectLst/>
+        </p:spPr>
+        <p:style>
+          <a:lnRef idx="1">
+            <a:schemeClr val="accent1"/>
+          </a:lnRef>
+          <a:fillRef idx="3">
+            <a:schemeClr val="accent1"/>
+          </a:fillRef>
+          <a:effectRef idx="2">
+            <a:schemeClr val="accent1"/>
+          </a:effectRef>
+          <a:fontRef idx="minor">
+            <a:schemeClr val="lt1"/>
+          </a:fontRef>
+        </p:style>
+        <p:txBody>
+          <a:bodyPr rtlCol="0" anchor="ctr" wrap="square" lIns="73152" rIns="64008"/>
+          <a:lstStyle/>
+          <a:p>
+            <a:pPr algn="l">
+              <a:lnSpc>
+                <a:spcPct val="100000"/>
+              </a:lnSpc>
+              <a:spcBef>
+                <a:spcPts val="0"/>
+              </a:spcBef>
+              <a:spcAft>
+                <a:spcPts val="0"/>
+              </a:spcAft>
+            </a:pPr>
+            <a:r>
+              <a:rPr sz="950" b="1">
+                <a:solidFill>
+                  <a:srgbClr val="9C7422"/>
+                </a:solidFill>
+                <a:latin typeface="Calibri"/>
+              </a:rPr>
+              <a:t>3 · </a:t>
+            </a:r>
+            <a:r>
+              <a:rPr sz="950" b="1">
+                <a:solidFill>
+                  <a:srgbClr val="16203C"/>
+                </a:solidFill>
+                <a:latin typeface="Calibri"/>
+              </a:rPr>
+              <a:t>Paste → Sort into items</a:t>
+            </a:r>
+          </a:p>
+        </p:txBody>
+      </p:sp>
+      <p:sp>
+        <p:nvSpPr>
+          <p:cNvPr id="20" name="Rounded Rectangle 19"/>
+          <p:cNvSpPr/>
+          <p:nvPr/>
+        </p:nvSpPr>
+        <p:spPr>
+          <a:xfrm>
+            <a:off x="5724144" y="2999232"/>
+            <a:ext cx="1965960" cy="658368"/>
+          </a:xfrm>
+          <a:prstGeom prst="roundRect">
+            <a:avLst>
+              <a:gd name="adj" fmla="val 10000"/>
+            </a:avLst>
+          </a:prstGeom>
+          <a:solidFill>
+            <a:srgbClr val="FFFFFF"/>
+          </a:solidFill>
+          <a:ln w="15875">
+            <a:solidFill>
+              <a:srgbClr val="B0872A"/>
+            </a:solidFill>
+          </a:ln>
+          <a:effectLst/>
+        </p:spPr>
+        <p:style>
+          <a:lnRef idx="1">
+            <a:schemeClr val="accent1"/>
+          </a:lnRef>
+          <a:fillRef idx="3">
+            <a:schemeClr val="accent1"/>
+          </a:fillRef>
+          <a:effectRef idx="2">
+            <a:schemeClr val="accent1"/>
+          </a:effectRef>
+          <a:fontRef idx="minor">
+            <a:schemeClr val="lt1"/>
+          </a:fontRef>
+        </p:style>
+        <p:txBody>
+          <a:bodyPr rtlCol="0" anchor="ctr" wrap="square" lIns="73152" rIns="64008"/>
+          <a:lstStyle/>
+          <a:p>
+            <a:pPr algn="l">
+              <a:lnSpc>
+                <a:spcPct val="100000"/>
+              </a:lnSpc>
+              <a:spcBef>
+                <a:spcPts val="0"/>
+              </a:spcBef>
+              <a:spcAft>
+                <a:spcPts val="0"/>
+              </a:spcAft>
+            </a:pPr>
+            <a:r>
+              <a:rPr sz="950" b="1">
+                <a:solidFill>
+                  <a:srgbClr val="9C7422"/>
+                </a:solidFill>
+                <a:latin typeface="Calibri"/>
+              </a:rPr>
+              <a:t>4 · </a:t>
+            </a:r>
+            <a:r>
+              <a:rPr sz="950" b="1">
+                <a:solidFill>
+                  <a:srgbClr val="16203C"/>
+                </a:solidFill>
+                <a:latin typeface="Calibri"/>
+              </a:rPr>
+              <a:t>Review: Keep · edit · notes</a:t>
+            </a:r>
+          </a:p>
+        </p:txBody>
+      </p:sp>
+      <p:sp>
+        <p:nvSpPr>
+          <p:cNvPr id="21" name="Rounded Rectangle 20"/>
+          <p:cNvSpPr/>
+          <p:nvPr/>
+        </p:nvSpPr>
+        <p:spPr>
+          <a:xfrm>
+            <a:off x="3611880" y="3712464"/>
+            <a:ext cx="4078224" cy="457200"/>
+          </a:xfrm>
+          <a:prstGeom prst="roundRect">
+            <a:avLst>
+              <a:gd name="adj" fmla="val 12000"/>
+            </a:avLst>
+          </a:prstGeom>
+          <a:solidFill>
+            <a:srgbClr val="FBE6D2"/>
+          </a:solidFill>
+          <a:ln w="15875">
+            <a:solidFill>
+              <a:srgbClr val="B06A17"/>
+            </a:solidFill>
+          </a:ln>
+          <a:effectLst/>
+        </p:spPr>
+        <p:style>
+          <a:lnRef idx="1">
+            <a:schemeClr val="accent1"/>
+          </a:lnRef>
+          <a:fillRef idx="3">
+            <a:schemeClr val="accent1"/>
+          </a:fillRef>
+          <a:effectRef idx="2">
+            <a:schemeClr val="accent1"/>
+          </a:effectRef>
+          <a:fontRef idx="minor">
+            <a:schemeClr val="lt1"/>
+          </a:fontRef>
+        </p:style>
+        <p:txBody>
+          <a:bodyPr rtlCol="0" anchor="ctr" wrap="square" lIns="73152" rIns="64008"/>
+          <a:lstStyle/>
+          <a:p>
+            <a:pPr algn="ctr">
+              <a:lnSpc>
+                <a:spcPct val="100000"/>
+              </a:lnSpc>
+              <a:spcBef>
+                <a:spcPts val="0"/>
+              </a:spcBef>
+              <a:spcAft>
+                <a:spcPts val="0"/>
+              </a:spcAft>
+            </a:pPr>
+            <a:r>
+              <a:rPr sz="950" b="1">
+                <a:solidFill>
+                  <a:srgbClr val="B06A17"/>
+                </a:solidFill>
+                <a:latin typeface="Calibri"/>
+              </a:rPr>
+              <a:t>◇ needs-clarification?  </a:t>
+            </a:r>
+            <a:r>
+              <a:rPr sz="900" b="0">
+                <a:solidFill>
+                  <a:srgbClr val="47517A"/>
+                </a:solidFill>
+                <a:latin typeface="Calibri"/>
+              </a:rPr>
+              <a:t>Yes → ask client ⟲   ·   No ↓</a:t>
+            </a:r>
+          </a:p>
+        </p:txBody>
+      </p:sp>
+      <p:sp>
+        <p:nvSpPr>
+          <p:cNvPr id="22" name="Rounded Rectangle 21"/>
+          <p:cNvSpPr/>
+          <p:nvPr/>
+        </p:nvSpPr>
+        <p:spPr>
+          <a:xfrm>
+            <a:off x="3611880" y="4242816"/>
+            <a:ext cx="1965960" cy="786384"/>
+          </a:xfrm>
+          <a:prstGeom prst="roundRect">
+            <a:avLst>
+              <a:gd name="adj" fmla="val 10000"/>
+            </a:avLst>
+          </a:prstGeom>
+          <a:solidFill>
+            <a:srgbClr val="FFFFFF"/>
+          </a:solidFill>
+          <a:ln w="15875">
+            <a:solidFill>
+              <a:srgbClr val="B0872A"/>
+            </a:solidFill>
+          </a:ln>
+          <a:effectLst/>
+        </p:spPr>
+        <p:style>
+          <a:lnRef idx="1">
+            <a:schemeClr val="accent1"/>
+          </a:lnRef>
+          <a:fillRef idx="3">
+            <a:schemeClr val="accent1"/>
+          </a:fillRef>
+          <a:effectRef idx="2">
+            <a:schemeClr val="accent1"/>
+          </a:effectRef>
+          <a:fontRef idx="minor">
+            <a:schemeClr val="lt1"/>
+          </a:fontRef>
+        </p:style>
+        <p:txBody>
+          <a:bodyPr rtlCol="0" anchor="ctr" wrap="square" lIns="73152" rIns="64008"/>
+          <a:lstStyle/>
+          <a:p>
+            <a:pPr algn="l">
+              <a:lnSpc>
+                <a:spcPct val="100000"/>
+              </a:lnSpc>
+              <a:spcBef>
+                <a:spcPts val="0"/>
+              </a:spcBef>
+              <a:spcAft>
+                <a:spcPts val="0"/>
+              </a:spcAft>
+            </a:pPr>
+            <a:r>
+              <a:rPr sz="950" b="1">
+                <a:solidFill>
+                  <a:srgbClr val="9C7422"/>
+                </a:solidFill>
+                <a:latin typeface="Calibri"/>
+              </a:rPr>
+              <a:t>5 · </a:t>
+            </a:r>
+            <a:r>
+              <a:rPr sz="950" b="1">
+                <a:solidFill>
+                  <a:srgbClr val="16203C"/>
+                </a:solidFill>
+                <a:latin typeface="Calibri"/>
+              </a:rPr>
+              <a:t>Confirm items</a:t>
+            </a:r>
+          </a:p>
+          <a:p>
+            <a:pPr algn="l">
+              <a:lnSpc>
+                <a:spcPct val="102000"/>
+              </a:lnSpc>
+              <a:spcBef>
+                <a:spcPts val="200"/>
+              </a:spcBef>
+              <a:spcAft>
+                <a:spcPts val="0"/>
+              </a:spcAft>
+            </a:pPr>
+            <a:r>
+              <a:rPr sz="780" b="0">
+                <a:solidFill>
+                  <a:srgbClr val="47517A"/>
+                </a:solidFill>
+                <a:latin typeface="Calibri"/>
+              </a:rPr>
+              <a:t>commits guidance + watchlist · fills NO fields</a:t>
+            </a:r>
+          </a:p>
+        </p:txBody>
+      </p:sp>
+      <p:sp>
+        <p:nvSpPr>
+          <p:cNvPr id="23" name="Rounded Rectangle 22"/>
+          <p:cNvSpPr/>
+          <p:nvPr/>
+        </p:nvSpPr>
+        <p:spPr>
+          <a:xfrm>
+            <a:off x="5724144" y="4242816"/>
+            <a:ext cx="1965960" cy="786384"/>
+          </a:xfrm>
+          <a:prstGeom prst="roundRect">
+            <a:avLst>
+              <a:gd name="adj" fmla="val 10000"/>
+            </a:avLst>
+          </a:prstGeom>
+          <a:solidFill>
+            <a:srgbClr val="FFFFFF"/>
+          </a:solidFill>
+          <a:ln w="15875">
+            <a:solidFill>
+              <a:srgbClr val="B0872A"/>
+            </a:solidFill>
+          </a:ln>
+          <a:effectLst/>
+        </p:spPr>
+        <p:style>
+          <a:lnRef idx="1">
+            <a:schemeClr val="accent1"/>
+          </a:lnRef>
+          <a:fillRef idx="3">
+            <a:schemeClr val="accent1"/>
+          </a:fillRef>
+          <a:effectRef idx="2">
+            <a:schemeClr val="accent1"/>
+          </a:effectRef>
+          <a:fontRef idx="minor">
+            <a:schemeClr val="lt1"/>
+          </a:fontRef>
+        </p:style>
+        <p:txBody>
+          <a:bodyPr rtlCol="0" anchor="ctr" wrap="square" lIns="73152" rIns="64008"/>
+          <a:lstStyle/>
+          <a:p>
+            <a:pPr algn="l">
+              <a:lnSpc>
+                <a:spcPct val="100000"/>
+              </a:lnSpc>
+              <a:spcBef>
+                <a:spcPts val="0"/>
+              </a:spcBef>
+              <a:spcAft>
+                <a:spcPts val="0"/>
+              </a:spcAft>
+            </a:pPr>
+            <a:r>
+              <a:rPr sz="950" b="1">
+                <a:solidFill>
+                  <a:srgbClr val="9C7422"/>
+                </a:solidFill>
+                <a:latin typeface="Calibri"/>
+              </a:rPr>
+              <a:t>6 · </a:t>
+            </a:r>
+            <a:r>
+              <a:rPr sz="950" b="1">
+                <a:solidFill>
+                  <a:srgbClr val="16203C"/>
+                </a:solidFill>
+                <a:latin typeface="Calibri"/>
+              </a:rPr>
+              <a:t>Apply to allocation targets</a:t>
+            </a:r>
+          </a:p>
+          <a:p>
+            <a:pPr algn="l">
+              <a:lnSpc>
+                <a:spcPct val="102000"/>
+              </a:lnSpc>
+              <a:spcBef>
+                <a:spcPts val="200"/>
+              </a:spcBef>
+              <a:spcAft>
+                <a:spcPts val="0"/>
+              </a:spcAft>
+            </a:pPr>
+            <a:r>
+              <a:rPr sz="780" b="0">
+                <a:solidFill>
+                  <a:srgbClr val="47517A"/>
+                </a:solidFill>
+                <a:latin typeface="Calibri"/>
+              </a:rPr>
+              <a:t>only action that fills sleeves · optional · ⤶ fills 2</a:t>
+            </a:r>
+          </a:p>
+        </p:txBody>
+      </p:sp>
+      <p:sp>
+        <p:nvSpPr>
+          <p:cNvPr id="24" name="Rounded Rectangle 23"/>
+          <p:cNvSpPr/>
+          <p:nvPr/>
+        </p:nvSpPr>
+        <p:spPr>
+          <a:xfrm>
+            <a:off x="7891271" y="3575304"/>
             <a:ext cx="1627632" cy="868680"/>
           </a:xfrm>
           <a:prstGeom prst="roundRect">
@@ -4671,7 +5269,7 @@
                 </a:solidFill>
                 <a:latin typeface="Calibri"/>
               </a:rPr>
-              <a:t>1 · </a:t>
+              <a:t>7 · </a:t>
             </a:r>
             <a:r>
               <a:rPr sz="1000" b="1">
@@ -4702,605 +5300,7 @@
                 </a:solidFill>
                 <a:latin typeface="Calibri"/>
               </a:rPr>
-              <a:t>any time · independent of 2–3</a:t>
-            </a:r>
-          </a:p>
-        </p:txBody>
-      </p:sp>
-      <p:sp>
-        <p:nvSpPr>
-          <p:cNvPr id="18" name="Rounded Rectangle 17"/>
-          <p:cNvSpPr/>
-          <p:nvPr/>
-        </p:nvSpPr>
-        <p:spPr>
-          <a:xfrm>
-            <a:off x="3191256" y="3108960"/>
-            <a:ext cx="2066543" cy="932688"/>
-          </a:xfrm>
-          <a:prstGeom prst="roundRect">
-            <a:avLst>
-              <a:gd name="adj" fmla="val 10000"/>
-            </a:avLst>
-          </a:prstGeom>
-          <a:solidFill>
-            <a:srgbClr val="FFFFFF"/>
-          </a:solidFill>
-          <a:ln w="15875">
-            <a:solidFill>
-              <a:srgbClr val="B0872A"/>
-            </a:solidFill>
-          </a:ln>
-          <a:effectLst/>
-        </p:spPr>
-        <p:style>
-          <a:lnRef idx="1">
-            <a:schemeClr val="accent1"/>
-          </a:lnRef>
-          <a:fillRef idx="3">
-            <a:schemeClr val="accent1"/>
-          </a:fillRef>
-          <a:effectRef idx="2">
-            <a:schemeClr val="accent1"/>
-          </a:effectRef>
-          <a:fontRef idx="minor">
-            <a:schemeClr val="lt1"/>
-          </a:fontRef>
-        </p:style>
-        <p:txBody>
-          <a:bodyPr rtlCol="0" anchor="ctr" wrap="square" lIns="73152" rIns="64008"/>
-          <a:lstStyle/>
-          <a:p>
-            <a:pPr algn="l">
-              <a:lnSpc>
-                <a:spcPct val="100000"/>
-              </a:lnSpc>
-              <a:spcBef>
-                <a:spcPts val="0"/>
-              </a:spcBef>
-              <a:spcAft>
-                <a:spcPts val="0"/>
-              </a:spcAft>
-            </a:pPr>
-            <a:r>
-              <a:rPr sz="1000" b="1">
-                <a:solidFill>
-                  <a:srgbClr val="9C7422"/>
-                </a:solidFill>
-                <a:latin typeface="Calibri"/>
-              </a:rPr>
-              <a:t>2 · </a:t>
-            </a:r>
-            <a:r>
-              <a:rPr sz="1000" b="1">
-                <a:solidFill>
-                  <a:srgbClr val="16203C"/>
-                </a:solidFill>
-                <a:latin typeface="Calibri"/>
-              </a:rPr>
-              <a:t>Set mandate, risk &amp; ability</a:t>
-            </a:r>
-          </a:p>
-        </p:txBody>
-      </p:sp>
-      <p:sp>
-        <p:nvSpPr>
-          <p:cNvPr id="19" name="Rounded Rectangle 18"/>
-          <p:cNvSpPr/>
-          <p:nvPr/>
-        </p:nvSpPr>
-        <p:spPr>
-          <a:xfrm>
-            <a:off x="3191256" y="4114800"/>
-            <a:ext cx="2066543" cy="932688"/>
-          </a:xfrm>
-          <a:prstGeom prst="roundRect">
-            <a:avLst>
-              <a:gd name="adj" fmla="val 10000"/>
-            </a:avLst>
-          </a:prstGeom>
-          <a:solidFill>
-            <a:srgbClr val="FFFFFF"/>
-          </a:solidFill>
-          <a:ln w="15875">
-            <a:solidFill>
-              <a:srgbClr val="B0872A"/>
-            </a:solidFill>
-          </a:ln>
-          <a:effectLst/>
-        </p:spPr>
-        <p:style>
-          <a:lnRef idx="1">
-            <a:schemeClr val="accent1"/>
-          </a:lnRef>
-          <a:fillRef idx="3">
-            <a:schemeClr val="accent1"/>
-          </a:fillRef>
-          <a:effectRef idx="2">
-            <a:schemeClr val="accent1"/>
-          </a:effectRef>
-          <a:fontRef idx="minor">
-            <a:schemeClr val="lt1"/>
-          </a:fontRef>
-        </p:style>
-        <p:txBody>
-          <a:bodyPr rtlCol="0" anchor="ctr" wrap="square" lIns="73152" rIns="64008"/>
-          <a:lstStyle/>
-          <a:p>
-            <a:pPr algn="l">
-              <a:lnSpc>
-                <a:spcPct val="100000"/>
-              </a:lnSpc>
-              <a:spcBef>
-                <a:spcPts val="0"/>
-              </a:spcBef>
-              <a:spcAft>
-                <a:spcPts val="0"/>
-              </a:spcAft>
-            </a:pPr>
-            <a:r>
-              <a:rPr sz="1000" b="1">
-                <a:solidFill>
-                  <a:srgbClr val="9C7422"/>
-                </a:solidFill>
-                <a:latin typeface="Calibri"/>
-              </a:rPr>
-              <a:t>3 · </a:t>
-            </a:r>
-            <a:r>
-              <a:rPr sz="1000" b="1">
-                <a:solidFill>
-                  <a:srgbClr val="16203C"/>
-                </a:solidFill>
-                <a:latin typeface="Calibri"/>
-              </a:rPr>
-              <a:t>Set allocation targets &amp; limits</a:t>
-            </a:r>
-          </a:p>
-          <a:p>
-            <a:pPr algn="l">
-              <a:lnSpc>
-                <a:spcPct val="102000"/>
-              </a:lnSpc>
-              <a:spcBef>
-                <a:spcPts val="200"/>
-              </a:spcBef>
-              <a:spcAft>
-                <a:spcPts val="0"/>
-              </a:spcAft>
-            </a:pPr>
-            <a:r>
-              <a:rPr sz="830" b="0">
-                <a:solidFill>
-                  <a:srgbClr val="47517A"/>
-                </a:solidFill>
-                <a:latin typeface="Calibri"/>
-              </a:rPr>
-              <a:t>limits manual · sleeves can be pre-filled by 7</a:t>
-            </a:r>
-          </a:p>
-        </p:txBody>
-      </p:sp>
-      <p:sp>
-        <p:nvSpPr>
-          <p:cNvPr id="20" name="Rounded Rectangle 19"/>
-          <p:cNvSpPr/>
-          <p:nvPr/>
-        </p:nvSpPr>
-        <p:spPr>
-          <a:xfrm>
-            <a:off x="5458968" y="2999232"/>
-            <a:ext cx="1965960" cy="658368"/>
-          </a:xfrm>
-          <a:prstGeom prst="roundRect">
-            <a:avLst>
-              <a:gd name="adj" fmla="val 10000"/>
-            </a:avLst>
-          </a:prstGeom>
-          <a:solidFill>
-            <a:srgbClr val="FFFFFF"/>
-          </a:solidFill>
-          <a:ln w="15875">
-            <a:solidFill>
-              <a:srgbClr val="B0872A"/>
-            </a:solidFill>
-          </a:ln>
-          <a:effectLst/>
-        </p:spPr>
-        <p:style>
-          <a:lnRef idx="1">
-            <a:schemeClr val="accent1"/>
-          </a:lnRef>
-          <a:fillRef idx="3">
-            <a:schemeClr val="accent1"/>
-          </a:fillRef>
-          <a:effectRef idx="2">
-            <a:schemeClr val="accent1"/>
-          </a:effectRef>
-          <a:fontRef idx="minor">
-            <a:schemeClr val="lt1"/>
-          </a:fontRef>
-        </p:style>
-        <p:txBody>
-          <a:bodyPr rtlCol="0" anchor="ctr" wrap="square" lIns="73152" rIns="64008"/>
-          <a:lstStyle/>
-          <a:p>
-            <a:pPr algn="l">
-              <a:lnSpc>
-                <a:spcPct val="100000"/>
-              </a:lnSpc>
-              <a:spcBef>
-                <a:spcPts val="0"/>
-              </a:spcBef>
-              <a:spcAft>
-                <a:spcPts val="0"/>
-              </a:spcAft>
-            </a:pPr>
-            <a:r>
-              <a:rPr sz="950" b="1">
-                <a:solidFill>
-                  <a:srgbClr val="9C7422"/>
-                </a:solidFill>
-                <a:latin typeface="Calibri"/>
-              </a:rPr>
-              <a:t>4 · </a:t>
-            </a:r>
-            <a:r>
-              <a:rPr sz="950" b="1">
-                <a:solidFill>
-                  <a:srgbClr val="16203C"/>
-                </a:solidFill>
-                <a:latin typeface="Calibri"/>
-              </a:rPr>
-              <a:t>Paste → Sort into items</a:t>
-            </a:r>
-          </a:p>
-        </p:txBody>
-      </p:sp>
-      <p:sp>
-        <p:nvSpPr>
-          <p:cNvPr id="21" name="Rounded Rectangle 20"/>
-          <p:cNvSpPr/>
-          <p:nvPr/>
-        </p:nvSpPr>
-        <p:spPr>
-          <a:xfrm>
-            <a:off x="7571231" y="2999232"/>
-            <a:ext cx="1965960" cy="658368"/>
-          </a:xfrm>
-          <a:prstGeom prst="roundRect">
-            <a:avLst>
-              <a:gd name="adj" fmla="val 10000"/>
-            </a:avLst>
-          </a:prstGeom>
-          <a:solidFill>
-            <a:srgbClr val="FFFFFF"/>
-          </a:solidFill>
-          <a:ln w="15875">
-            <a:solidFill>
-              <a:srgbClr val="B0872A"/>
-            </a:solidFill>
-          </a:ln>
-          <a:effectLst/>
-        </p:spPr>
-        <p:style>
-          <a:lnRef idx="1">
-            <a:schemeClr val="accent1"/>
-          </a:lnRef>
-          <a:fillRef idx="3">
-            <a:schemeClr val="accent1"/>
-          </a:fillRef>
-          <a:effectRef idx="2">
-            <a:schemeClr val="accent1"/>
-          </a:effectRef>
-          <a:fontRef idx="minor">
-            <a:schemeClr val="lt1"/>
-          </a:fontRef>
-        </p:style>
-        <p:txBody>
-          <a:bodyPr rtlCol="0" anchor="ctr" wrap="square" lIns="73152" rIns="64008"/>
-          <a:lstStyle/>
-          <a:p>
-            <a:pPr algn="l">
-              <a:lnSpc>
-                <a:spcPct val="100000"/>
-              </a:lnSpc>
-              <a:spcBef>
-                <a:spcPts val="0"/>
-              </a:spcBef>
-              <a:spcAft>
-                <a:spcPts val="0"/>
-              </a:spcAft>
-            </a:pPr>
-            <a:r>
-              <a:rPr sz="950" b="1">
-                <a:solidFill>
-                  <a:srgbClr val="9C7422"/>
-                </a:solidFill>
-                <a:latin typeface="Calibri"/>
-              </a:rPr>
-              <a:t>5 · </a:t>
-            </a:r>
-            <a:r>
-              <a:rPr sz="950" b="1">
-                <a:solidFill>
-                  <a:srgbClr val="16203C"/>
-                </a:solidFill>
-                <a:latin typeface="Calibri"/>
-              </a:rPr>
-              <a:t>Review: Keep · edit · notes</a:t>
-            </a:r>
-          </a:p>
-        </p:txBody>
-      </p:sp>
-      <p:sp>
-        <p:nvSpPr>
-          <p:cNvPr id="22" name="Rounded Rectangle 21"/>
-          <p:cNvSpPr/>
-          <p:nvPr/>
-        </p:nvSpPr>
-        <p:spPr>
-          <a:xfrm>
-            <a:off x="5458968" y="3712464"/>
-            <a:ext cx="4078224" cy="457200"/>
-          </a:xfrm>
-          <a:prstGeom prst="roundRect">
-            <a:avLst>
-              <a:gd name="adj" fmla="val 12000"/>
-            </a:avLst>
-          </a:prstGeom>
-          <a:solidFill>
-            <a:srgbClr val="FBE6D2"/>
-          </a:solidFill>
-          <a:ln w="15875">
-            <a:solidFill>
-              <a:srgbClr val="B06A17"/>
-            </a:solidFill>
-          </a:ln>
-          <a:effectLst/>
-        </p:spPr>
-        <p:style>
-          <a:lnRef idx="1">
-            <a:schemeClr val="accent1"/>
-          </a:lnRef>
-          <a:fillRef idx="3">
-            <a:schemeClr val="accent1"/>
-          </a:fillRef>
-          <a:effectRef idx="2">
-            <a:schemeClr val="accent1"/>
-          </a:effectRef>
-          <a:fontRef idx="minor">
-            <a:schemeClr val="lt1"/>
-          </a:fontRef>
-        </p:style>
-        <p:txBody>
-          <a:bodyPr rtlCol="0" anchor="ctr" wrap="square" lIns="73152" rIns="64008"/>
-          <a:lstStyle/>
-          <a:p>
-            <a:pPr algn="ctr">
-              <a:lnSpc>
-                <a:spcPct val="100000"/>
-              </a:lnSpc>
-              <a:spcBef>
-                <a:spcPts val="0"/>
-              </a:spcBef>
-              <a:spcAft>
-                <a:spcPts val="0"/>
-              </a:spcAft>
-            </a:pPr>
-            <a:r>
-              <a:rPr sz="950" b="1">
-                <a:solidFill>
-                  <a:srgbClr val="B06A17"/>
-                </a:solidFill>
-                <a:latin typeface="Calibri"/>
-              </a:rPr>
-              <a:t>◇ needs-clarification?  </a:t>
-            </a:r>
-            <a:r>
-              <a:rPr sz="900" b="0">
-                <a:solidFill>
-                  <a:srgbClr val="47517A"/>
-                </a:solidFill>
-                <a:latin typeface="Calibri"/>
-              </a:rPr>
-              <a:t>Yes → ask client ⟲   ·   No ↓</a:t>
-            </a:r>
-          </a:p>
-        </p:txBody>
-      </p:sp>
-      <p:sp>
-        <p:nvSpPr>
-          <p:cNvPr id="23" name="Rounded Rectangle 22"/>
-          <p:cNvSpPr/>
-          <p:nvPr/>
-        </p:nvSpPr>
-        <p:spPr>
-          <a:xfrm>
-            <a:off x="5458968" y="4242816"/>
-            <a:ext cx="1965960" cy="786384"/>
-          </a:xfrm>
-          <a:prstGeom prst="roundRect">
-            <a:avLst>
-              <a:gd name="adj" fmla="val 10000"/>
-            </a:avLst>
-          </a:prstGeom>
-          <a:solidFill>
-            <a:srgbClr val="FFFFFF"/>
-          </a:solidFill>
-          <a:ln w="15875">
-            <a:solidFill>
-              <a:srgbClr val="B0872A"/>
-            </a:solidFill>
-          </a:ln>
-          <a:effectLst/>
-        </p:spPr>
-        <p:style>
-          <a:lnRef idx="1">
-            <a:schemeClr val="accent1"/>
-          </a:lnRef>
-          <a:fillRef idx="3">
-            <a:schemeClr val="accent1"/>
-          </a:fillRef>
-          <a:effectRef idx="2">
-            <a:schemeClr val="accent1"/>
-          </a:effectRef>
-          <a:fontRef idx="minor">
-            <a:schemeClr val="lt1"/>
-          </a:fontRef>
-        </p:style>
-        <p:txBody>
-          <a:bodyPr rtlCol="0" anchor="ctr" wrap="square" lIns="73152" rIns="64008"/>
-          <a:lstStyle/>
-          <a:p>
-            <a:pPr algn="l">
-              <a:lnSpc>
-                <a:spcPct val="100000"/>
-              </a:lnSpc>
-              <a:spcBef>
-                <a:spcPts val="0"/>
-              </a:spcBef>
-              <a:spcAft>
-                <a:spcPts val="0"/>
-              </a:spcAft>
-            </a:pPr>
-            <a:r>
-              <a:rPr sz="950" b="1">
-                <a:solidFill>
-                  <a:srgbClr val="9C7422"/>
-                </a:solidFill>
-                <a:latin typeface="Calibri"/>
-              </a:rPr>
-              <a:t>6 · </a:t>
-            </a:r>
-            <a:r>
-              <a:rPr sz="950" b="1">
-                <a:solidFill>
-                  <a:srgbClr val="16203C"/>
-                </a:solidFill>
-                <a:latin typeface="Calibri"/>
-              </a:rPr>
-              <a:t>Confirm items</a:t>
-            </a:r>
-          </a:p>
-          <a:p>
-            <a:pPr algn="l">
-              <a:lnSpc>
-                <a:spcPct val="102000"/>
-              </a:lnSpc>
-              <a:spcBef>
-                <a:spcPts val="200"/>
-              </a:spcBef>
-              <a:spcAft>
-                <a:spcPts val="0"/>
-              </a:spcAft>
-            </a:pPr>
-            <a:r>
-              <a:rPr sz="780" b="0">
-                <a:solidFill>
-                  <a:srgbClr val="47517A"/>
-                </a:solidFill>
-                <a:latin typeface="Calibri"/>
-              </a:rPr>
-              <a:t>commits guidance + watchlist · fills NO fields</a:t>
-            </a:r>
-          </a:p>
-        </p:txBody>
-      </p:sp>
-      <p:sp>
-        <p:nvSpPr>
-          <p:cNvPr id="24" name="Rounded Rectangle 23"/>
-          <p:cNvSpPr/>
-          <p:nvPr/>
-        </p:nvSpPr>
-        <p:spPr>
-          <a:xfrm>
-            <a:off x="7571231" y="4242816"/>
-            <a:ext cx="1965960" cy="786384"/>
-          </a:xfrm>
-          <a:prstGeom prst="roundRect">
-            <a:avLst>
-              <a:gd name="adj" fmla="val 10000"/>
-            </a:avLst>
-          </a:prstGeom>
-          <a:solidFill>
-            <a:srgbClr val="FFFFFF"/>
-          </a:solidFill>
-          <a:ln w="15875">
-            <a:solidFill>
-              <a:srgbClr val="B0872A"/>
-            </a:solidFill>
-          </a:ln>
-          <a:effectLst/>
-        </p:spPr>
-        <p:style>
-          <a:lnRef idx="1">
-            <a:schemeClr val="accent1"/>
-          </a:lnRef>
-          <a:fillRef idx="3">
-            <a:schemeClr val="accent1"/>
-          </a:fillRef>
-          <a:effectRef idx="2">
-            <a:schemeClr val="accent1"/>
-          </a:effectRef>
-          <a:fontRef idx="minor">
-            <a:schemeClr val="lt1"/>
-          </a:fontRef>
-        </p:style>
-        <p:txBody>
-          <a:bodyPr rtlCol="0" anchor="ctr" wrap="square" lIns="73152" rIns="64008"/>
-          <a:lstStyle/>
-          <a:p>
-            <a:pPr algn="l">
-              <a:lnSpc>
-                <a:spcPct val="100000"/>
-              </a:lnSpc>
-              <a:spcBef>
-                <a:spcPts val="0"/>
-              </a:spcBef>
-              <a:spcAft>
-                <a:spcPts val="0"/>
-              </a:spcAft>
-            </a:pPr>
-            <a:r>
-              <a:rPr sz="950" b="1">
-                <a:solidFill>
-                  <a:srgbClr val="9C7422"/>
-                </a:solidFill>
-                <a:latin typeface="Calibri"/>
-              </a:rPr>
-              <a:t>7 · </a:t>
-            </a:r>
-            <a:r>
-              <a:rPr sz="950" b="1">
-                <a:solidFill>
-                  <a:srgbClr val="16203C"/>
-                </a:solidFill>
-                <a:latin typeface="Calibri"/>
-              </a:rPr>
-              <a:t>Apply to allocation targets</a:t>
-            </a:r>
-          </a:p>
-          <a:p>
-            <a:pPr algn="l">
-              <a:lnSpc>
-                <a:spcPct val="102000"/>
-              </a:lnSpc>
-              <a:spcBef>
-                <a:spcPts val="200"/>
-              </a:spcBef>
-              <a:spcAft>
-                <a:spcPts val="0"/>
-              </a:spcAft>
-            </a:pPr>
-            <a:r>
-              <a:rPr sz="780" b="0">
-                <a:solidFill>
-                  <a:srgbClr val="47517A"/>
-                </a:solidFill>
-                <a:latin typeface="Calibri"/>
-              </a:rPr>
-              <a:t>only action that fills sleeves · optional · ⤶ fills 3</a:t>
+              <a:t>after policy above is set · then live</a:t>
             </a:r>
           </a:p>
         </p:txBody>
@@ -5313,7 +5313,7 @@
         </p:nvSpPr>
         <p:spPr>
           <a:xfrm>
-            <a:off x="9738360" y="3108960"/>
+            <a:off x="9738359" y="3108960"/>
             <a:ext cx="2039112" cy="932688"/>
           </a:xfrm>
           <a:prstGeom prst="roundRect">
@@ -5389,7 +5389,7 @@
         </p:nvSpPr>
         <p:spPr>
           <a:xfrm>
-            <a:off x="9738360" y="4114800"/>
+            <a:off x="9738359" y="4114800"/>
             <a:ext cx="2039112" cy="932688"/>
           </a:xfrm>
           <a:prstGeom prst="roundRect">
@@ -5487,187 +5487,7 @@
         </p:nvSpPr>
         <p:spPr>
           <a:xfrm>
-            <a:off x="1344168" y="5376672"/>
-            <a:ext cx="1627632" cy="1005840"/>
-          </a:xfrm>
-          <a:prstGeom prst="roundRect">
-            <a:avLst>
-              <a:gd name="adj" fmla="val 10000"/>
-            </a:avLst>
-          </a:prstGeom>
-          <a:solidFill>
-            <a:srgbClr val="FFFFFF"/>
-          </a:solidFill>
-          <a:ln w="12700">
-            <a:solidFill>
-              <a:srgbClr val="C8CDDD"/>
-            </a:solidFill>
-            <a:prstDash val="dash"/>
-          </a:ln>
-          <a:effectLst/>
-        </p:spPr>
-        <p:style>
-          <a:lnRef idx="1">
-            <a:schemeClr val="accent1"/>
-          </a:lnRef>
-          <a:fillRef idx="3">
-            <a:schemeClr val="accent1"/>
-          </a:fillRef>
-          <a:effectRef idx="2">
-            <a:schemeClr val="accent1"/>
-          </a:effectRef>
-          <a:fontRef idx="minor">
-            <a:schemeClr val="lt1"/>
-          </a:fontRef>
-        </p:style>
-        <p:txBody>
-          <a:bodyPr rtlCol="0" anchor="ctr" wrap="square" lIns="73152" rIns="64008"/>
-          <a:lstStyle/>
-          <a:p>
-            <a:pPr algn="l">
-              <a:lnSpc>
-                <a:spcPct val="100000"/>
-              </a:lnSpc>
-              <a:spcBef>
-                <a:spcPts val="0"/>
-              </a:spcBef>
-              <a:spcAft>
-                <a:spcPts val="0"/>
-              </a:spcAft>
-            </a:pPr>
-            <a:r>
-              <a:rPr sz="800" b="1">
-                <a:solidFill>
-                  <a:srgbClr val="838CAD"/>
-                </a:solidFill>
-                <a:latin typeface="Calibri"/>
-              </a:rPr>
-              <a:t>⚙ AUTO</a:t>
-            </a:r>
-          </a:p>
-          <a:p>
-            <a:pPr algn="l">
-              <a:lnSpc>
-                <a:spcPct val="100000"/>
-              </a:lnSpc>
-              <a:spcBef>
-                <a:spcPts val="200"/>
-              </a:spcBef>
-              <a:spcAft>
-                <a:spcPts val="0"/>
-              </a:spcAft>
-            </a:pPr>
-            <a:r>
-              <a:rPr sz="1000" b="1">
-                <a:solidFill>
-                  <a:srgbClr val="47517A"/>
-                </a:solidFill>
-                <a:latin typeface="Calibri"/>
-              </a:rPr>
-              <a:t>Parse → build the book</a:t>
-            </a:r>
-          </a:p>
-        </p:txBody>
-      </p:sp>
-      <p:sp>
-        <p:nvSpPr>
-          <p:cNvPr id="28" name="Rounded Rectangle 27"/>
-          <p:cNvSpPr/>
-          <p:nvPr/>
-        </p:nvSpPr>
-        <p:spPr>
-          <a:xfrm>
-            <a:off x="3191256" y="5376672"/>
-            <a:ext cx="2066543" cy="1005840"/>
-          </a:xfrm>
-          <a:prstGeom prst="roundRect">
-            <a:avLst>
-              <a:gd name="adj" fmla="val 10000"/>
-            </a:avLst>
-          </a:prstGeom>
-          <a:solidFill>
-            <a:srgbClr val="FFFFFF"/>
-          </a:solidFill>
-          <a:ln w="12700">
-            <a:solidFill>
-              <a:srgbClr val="C8CDDD"/>
-            </a:solidFill>
-            <a:prstDash val="dash"/>
-          </a:ln>
-          <a:effectLst/>
-        </p:spPr>
-        <p:style>
-          <a:lnRef idx="1">
-            <a:schemeClr val="accent1"/>
-          </a:lnRef>
-          <a:fillRef idx="3">
-            <a:schemeClr val="accent1"/>
-          </a:fillRef>
-          <a:effectRef idx="2">
-            <a:schemeClr val="accent1"/>
-          </a:effectRef>
-          <a:fontRef idx="minor">
-            <a:schemeClr val="lt1"/>
-          </a:fontRef>
-        </p:style>
-        <p:txBody>
-          <a:bodyPr rtlCol="0" anchor="ctr" wrap="square" lIns="73152" rIns="64008"/>
-          <a:lstStyle/>
-          <a:p>
-            <a:pPr algn="l">
-              <a:lnSpc>
-                <a:spcPct val="100000"/>
-              </a:lnSpc>
-              <a:spcBef>
-                <a:spcPts val="0"/>
-              </a:spcBef>
-              <a:spcAft>
-                <a:spcPts val="0"/>
-              </a:spcAft>
-            </a:pPr>
-            <a:r>
-              <a:rPr sz="800" b="1">
-                <a:solidFill>
-                  <a:srgbClr val="838CAD"/>
-                </a:solidFill>
-                <a:latin typeface="Calibri"/>
-              </a:rPr>
-              <a:t>⚙ AUTO · LIVE</a:t>
-            </a:r>
-          </a:p>
-          <a:p>
-            <a:pPr algn="l">
-              <a:lnSpc>
-                <a:spcPct val="100000"/>
-              </a:lnSpc>
-              <a:spcBef>
-                <a:spcPts val="200"/>
-              </a:spcBef>
-              <a:spcAft>
-                <a:spcPts val="0"/>
-              </a:spcAft>
-            </a:pPr>
-            <a:r>
-              <a:rPr sz="1000" b="1">
-                <a:solidFill>
-                  <a:srgbClr val="47517A"/>
-                </a:solidFill>
-                <a:latin typeface="Calibri"/>
-              </a:rPr>
-              <a:t>Compute allocation, drift, suitability</a:t>
-            </a:r>
-          </a:p>
-        </p:txBody>
-      </p:sp>
-      <p:sp>
-        <p:nvSpPr>
-          <p:cNvPr id="29" name="Rounded Rectangle 28"/>
-          <p:cNvSpPr/>
-          <p:nvPr/>
-        </p:nvSpPr>
-        <p:spPr>
-          <a:xfrm>
-            <a:off x="5458968" y="5376672"/>
+            <a:off x="3611880" y="5376672"/>
             <a:ext cx="1975104" cy="1005840"/>
           </a:xfrm>
           <a:prstGeom prst="roundRect">
@@ -5722,7 +5542,7 @@
                 </a:solidFill>
                 <a:latin typeface="Calibri"/>
               </a:rPr>
-              <a:t>⚙ ON CONFIRM</a:t>
+              <a:t>⚙ AUTO</a:t>
             </a:r>
           </a:p>
           <a:p>
@@ -5744,7 +5564,7 @@
                 </a:solidFill>
                 <a:latin typeface="Calibri"/>
               </a:rPr>
-              <a:t>Watchlist + guidance</a:t>
+              <a:t>Classify each ask</a:t>
             </a:r>
           </a:p>
           <a:p>
@@ -5766,20 +5586,20 @@
                 </a:solidFill>
                 <a:latin typeface="Calibri"/>
               </a:rPr>
-              <a:t>unclear items held out</a:t>
-            </a:r>
-          </a:p>
-        </p:txBody>
-      </p:sp>
-      <p:sp>
-        <p:nvSpPr>
-          <p:cNvPr id="30" name="Rounded Rectangle 29"/>
+              <a:t>copies levels &amp; weights</a:t>
+            </a:r>
+          </a:p>
+        </p:txBody>
+      </p:sp>
+      <p:sp>
+        <p:nvSpPr>
+          <p:cNvPr id="28" name="Rounded Rectangle 27"/>
           <p:cNvSpPr/>
           <p:nvPr/>
         </p:nvSpPr>
         <p:spPr>
           <a:xfrm>
-            <a:off x="7562088" y="5376672"/>
+            <a:off x="5715000" y="5376672"/>
             <a:ext cx="1975104" cy="1005840"/>
           </a:xfrm>
           <a:prstGeom prst="roundRect">
@@ -5834,7 +5654,7 @@
                 </a:solidFill>
                 <a:latin typeface="Calibri"/>
               </a:rPr>
-              <a:t>⚙ IF WEIGHTS GIVEN</a:t>
+              <a:t>⚙ ON CONFIRM</a:t>
             </a:r>
           </a:p>
           <a:p>
@@ -5856,7 +5676,7 @@
                 </a:solidFill>
                 <a:latin typeface="Calibri"/>
               </a:rPr>
-              <a:t>Builds Proposed allocation</a:t>
+              <a:t>Watchlist + guidance</a:t>
             </a:r>
           </a:p>
           <a:p>
@@ -5878,7 +5698,187 @@
                 </a:solidFill>
                 <a:latin typeface="Calibri"/>
               </a:rPr>
-              <a:t>you Apply it in 7</a:t>
+              <a:t>+ builds Proposed allocation</a:t>
+            </a:r>
+          </a:p>
+        </p:txBody>
+      </p:sp>
+      <p:sp>
+        <p:nvSpPr>
+          <p:cNvPr id="29" name="Rounded Rectangle 28"/>
+          <p:cNvSpPr/>
+          <p:nvPr/>
+        </p:nvSpPr>
+        <p:spPr>
+          <a:xfrm>
+            <a:off x="7891271" y="5321807"/>
+            <a:ext cx="1627632" cy="548640"/>
+          </a:xfrm>
+          <a:prstGeom prst="roundRect">
+            <a:avLst>
+              <a:gd name="adj" fmla="val 10000"/>
+            </a:avLst>
+          </a:prstGeom>
+          <a:solidFill>
+            <a:srgbClr val="FFFFFF"/>
+          </a:solidFill>
+          <a:ln w="12700">
+            <a:solidFill>
+              <a:srgbClr val="C8CDDD"/>
+            </a:solidFill>
+            <a:prstDash val="dash"/>
+          </a:ln>
+          <a:effectLst/>
+        </p:spPr>
+        <p:style>
+          <a:lnRef idx="1">
+            <a:schemeClr val="accent1"/>
+          </a:lnRef>
+          <a:fillRef idx="3">
+            <a:schemeClr val="accent1"/>
+          </a:fillRef>
+          <a:effectRef idx="2">
+            <a:schemeClr val="accent1"/>
+          </a:effectRef>
+          <a:fontRef idx="minor">
+            <a:schemeClr val="lt1"/>
+          </a:fontRef>
+        </p:style>
+        <p:txBody>
+          <a:bodyPr rtlCol="0" anchor="ctr" wrap="square" lIns="73152" rIns="64008"/>
+          <a:lstStyle/>
+          <a:p>
+            <a:pPr algn="l">
+              <a:lnSpc>
+                <a:spcPct val="100000"/>
+              </a:lnSpc>
+              <a:spcBef>
+                <a:spcPts val="0"/>
+              </a:spcBef>
+              <a:spcAft>
+                <a:spcPts val="0"/>
+              </a:spcAft>
+            </a:pPr>
+            <a:r>
+              <a:rPr sz="800" b="1">
+                <a:solidFill>
+                  <a:srgbClr val="838CAD"/>
+                </a:solidFill>
+                <a:latin typeface="Calibri"/>
+              </a:rPr>
+              <a:t>⚙ ON ANALYSE</a:t>
+            </a:r>
+          </a:p>
+          <a:p>
+            <a:pPr algn="l">
+              <a:lnSpc>
+                <a:spcPct val="100000"/>
+              </a:lnSpc>
+              <a:spcBef>
+                <a:spcPts val="200"/>
+              </a:spcBef>
+              <a:spcAft>
+                <a:spcPts val="0"/>
+              </a:spcAft>
+            </a:pPr>
+            <a:r>
+              <a:rPr sz="1000" b="1">
+                <a:solidFill>
+                  <a:srgbClr val="47517A"/>
+                </a:solidFill>
+                <a:latin typeface="Calibri"/>
+              </a:rPr>
+              <a:t>Parse → build the book</a:t>
+            </a:r>
+          </a:p>
+        </p:txBody>
+      </p:sp>
+      <p:sp>
+        <p:nvSpPr>
+          <p:cNvPr id="30" name="Rounded Rectangle 29"/>
+          <p:cNvSpPr/>
+          <p:nvPr/>
+        </p:nvSpPr>
+        <p:spPr>
+          <a:xfrm>
+            <a:off x="7891271" y="5925312"/>
+            <a:ext cx="1627632" cy="548640"/>
+          </a:xfrm>
+          <a:prstGeom prst="roundRect">
+            <a:avLst>
+              <a:gd name="adj" fmla="val 10000"/>
+            </a:avLst>
+          </a:prstGeom>
+          <a:solidFill>
+            <a:srgbClr val="FFFFFF"/>
+          </a:solidFill>
+          <a:ln w="12700">
+            <a:solidFill>
+              <a:srgbClr val="C8CDDD"/>
+            </a:solidFill>
+            <a:prstDash val="dash"/>
+          </a:ln>
+          <a:effectLst/>
+        </p:spPr>
+        <p:style>
+          <a:lnRef idx="1">
+            <a:schemeClr val="accent1"/>
+          </a:lnRef>
+          <a:fillRef idx="3">
+            <a:schemeClr val="accent1"/>
+          </a:fillRef>
+          <a:effectRef idx="2">
+            <a:schemeClr val="accent1"/>
+          </a:effectRef>
+          <a:fontRef idx="minor">
+            <a:schemeClr val="lt1"/>
+          </a:fontRef>
+        </p:style>
+        <p:txBody>
+          <a:bodyPr rtlCol="0" anchor="ctr" wrap="square" lIns="73152" rIns="64008"/>
+          <a:lstStyle/>
+          <a:p>
+            <a:pPr algn="l">
+              <a:lnSpc>
+                <a:spcPct val="100000"/>
+              </a:lnSpc>
+              <a:spcBef>
+                <a:spcPts val="0"/>
+              </a:spcBef>
+              <a:spcAft>
+                <a:spcPts val="0"/>
+              </a:spcAft>
+            </a:pPr>
+            <a:r>
+              <a:rPr sz="800" b="1">
+                <a:solidFill>
+                  <a:srgbClr val="838CAD"/>
+                </a:solidFill>
+                <a:latin typeface="Calibri"/>
+              </a:rPr>
+              <a:t>⚙ AUTO · LIVE</a:t>
+            </a:r>
+          </a:p>
+          <a:p>
+            <a:pPr algn="l">
+              <a:lnSpc>
+                <a:spcPct val="100000"/>
+              </a:lnSpc>
+              <a:spcBef>
+                <a:spcPts val="200"/>
+              </a:spcBef>
+              <a:spcAft>
+                <a:spcPts val="0"/>
+              </a:spcAft>
+            </a:pPr>
+            <a:r>
+              <a:rPr sz="1000" b="1">
+                <a:solidFill>
+                  <a:srgbClr val="47517A"/>
+                </a:solidFill>
+                <a:latin typeface="Calibri"/>
+              </a:rPr>
+              <a:t>Compute allocation, drift</a:t>
             </a:r>
           </a:p>
         </p:txBody>
@@ -5891,7 +5891,7 @@
         </p:nvSpPr>
         <p:spPr>
           <a:xfrm>
-            <a:off x="9738360" y="5376672"/>
+            <a:off x="9738359" y="5376672"/>
             <a:ext cx="2039112" cy="1005840"/>
           </a:xfrm>
           <a:prstGeom prst="roundRect">
@@ -6033,7 +6033,7 @@
                 </a:solidFill>
                 <a:latin typeface="Calibri"/>
               </a:rPr>
-              <a:t>Key point: setup (1–7) is any-order; Confirm (6) fills no fields; allocations only via Apply (7); limits always manual.</a:t>
+              <a:t>Recommended order: set the policy (1–6) first, then Analyse (7). Confirm (5) fills no fields; allocations only via Apply (6); limits always manual.</a:t>
             </a:r>
           </a:p>
         </p:txBody>

</xml_diff>

<commit_message>
v8: docs — enforcement tiers across swimlane, design note, workflow decks
- New partner artifact tactical_enforcement_note.html: the client's message
  mapped tier-by-tier (enforced/monitored/advisory) with the honest "how wide
  is the door" read.
- Swimlane (HTML + PPTX): copilot lane now tags tiers and applies 🔒 triggers
  at Analyse; answer/footer note the enforced exception; bumped to v8.
- Design note (md + HTML): new "Enforcement tiers" section + refreshed
  built/next lists.
- Workflow 6-slide + one-pager (HTML + PPTX): guardrail reframed from absolute
  ("never a number") to tiered ("can gate, never invent"); bumped to v8.
- Regenerated all decks; added Tactical_Swimlane.pdf (+ workflow/onepager PDFs).

Co-Authored-By: Claude Opus 4.8 <noreply@anthropic.com>
</commit_message>
<xml_diff>
--- a/Tactical_Swimlane.pptx
+++ b/Tactical_Swimlane.pptx
@@ -3135,7 +3135,7 @@
                 </a:solidFill>
                 <a:latin typeface="Calibri"/>
               </a:rPr>
-              <a:t>MERIDIAN FAMILY OFFICE COPILOT · v7</a:t>
+              <a:t>MERIDIAN FAMILY OFFICE COPILOT · v8</a:t>
             </a:r>
           </a:p>
         </p:txBody>
@@ -3512,8 +3512,8 @@
         </p:nvSpPr>
         <p:spPr>
           <a:xfrm>
-            <a:off x="731520" y="5989320"/>
-            <a:ext cx="10725912" cy="804672"/>
+            <a:off x="731520" y="5943600"/>
+            <a:ext cx="10725912" cy="868680"/>
           </a:xfrm>
           <a:prstGeom prst="roundRect">
             <a:avLst>
@@ -3548,7 +3548,7 @@
           <a:p>
             <a:pPr algn="l">
               <a:lnSpc>
-                <a:spcPct val="106000"/>
+                <a:spcPct val="104000"/>
               </a:lnSpc>
               <a:spcBef>
                 <a:spcPts val="0"/>
@@ -3558,22 +3558,22 @@
               </a:spcAft>
             </a:pPr>
             <a:r>
-              <a:rPr sz="1200" b="1">
+              <a:rPr sz="1150" b="1">
                 <a:solidFill>
                   <a:srgbClr val="B0872A"/>
                 </a:solidFill>
                 <a:latin typeface="Calibri"/>
               </a:rPr>
-              <a:t>Order &amp; Analyse:  </a:t>
-            </a:r>
-            <a:r>
-              <a:rPr sz="1200" b="0">
+              <a:t>Order, Analyse &amp; the v8 exception:  </a:t>
+            </a:r>
+            <a:r>
+              <a:rPr sz="1150" b="0">
                 <a:solidFill>
                   <a:srgbClr val="FFFFFF"/>
                 </a:solidFill>
                 <a:latin typeface="Calibri"/>
               </a:rPr>
-              <a:t>Set the mandate / risk / allocations first, then press Analyse — so the first analysis already reflects the client's policy (analysing first computes against the default preset). After Confirm the views update live; no re-Analyse.</a:t>
+              <a:t>Set the mandate / risk / allocations first, then Analyse — so the first read reflects the policy. Confirm still fills no field; the one exception is a 🔒 enforced price trigger (e.g. “gold below $4,000”), which gates a rebalance buy at Analyse using a sourced live price — it can flag or hold a trade, never invent one.</a:t>
             </a:r>
           </a:p>
         </p:txBody>
@@ -3642,7 +3642,7 @@
                 </a:solidFill>
                 <a:latin typeface="Calibri"/>
               </a:rPr>
-              <a:t>MERIDIAN FAMILY OFFICE COPILOT · v7 · PROCESS</a:t>
+              <a:t>MERIDIAN FAMILY OFFICE COPILOT · v8 · PROCESS</a:t>
             </a:r>
           </a:p>
         </p:txBody>
@@ -5564,7 +5564,7 @@
                 </a:solidFill>
                 <a:latin typeface="Calibri"/>
               </a:rPr>
-              <a:t>Classify each ask</a:t>
+              <a:t>Classify + tag tier</a:t>
             </a:r>
           </a:p>
           <a:p>
@@ -5586,7 +5586,7 @@
                 </a:solidFill>
                 <a:latin typeface="Calibri"/>
               </a:rPr>
-              <a:t>copies levels &amp; weights</a:t>
+              <a:t>🔒 / 📡 / 📝 per item</a:t>
             </a:r>
           </a:p>
         </p:txBody>
@@ -5878,7 +5878,29 @@
                 </a:solidFill>
                 <a:latin typeface="Calibri"/>
               </a:rPr>
-              <a:t>Compute allocation, drift</a:t>
+              <a:t>Compute + apply 🔒 triggers</a:t>
+            </a:r>
+          </a:p>
+          <a:p>
+            <a:pPr algn="l">
+              <a:lnSpc>
+                <a:spcPct val="100000"/>
+              </a:lnSpc>
+              <a:spcBef>
+                <a:spcPts val="200"/>
+              </a:spcBef>
+              <a:spcAft>
+                <a:spcPts val="0"/>
+              </a:spcAft>
+            </a:pPr>
+            <a:r>
+              <a:rPr sz="830" b="0">
+                <a:solidFill>
+                  <a:srgbClr val="47517A"/>
+                </a:solidFill>
+                <a:latin typeface="Calibri"/>
+              </a:rPr>
+              <a:t>gates buys vs live price</a:t>
             </a:r>
           </a:p>
         </p:txBody>
@@ -6033,7 +6055,7 @@
                 </a:solidFill>
                 <a:latin typeface="Calibri"/>
               </a:rPr>
-              <a:t>Recommended order: set the policy (1–6) first, then Analyse (7). Confirm (5) fills no fields; allocations only via Apply (6); limits always manual.</a:t>
+              <a:t>Recommended order: set the policy (1–6) first, then Analyse (7). Confirm (5) fills no fields; allocations only via Apply (6); limits manual. v8: a 🔒 enforced price trigger gates a buy at Analyse (vs a sourced live price); 📡/📝 items never touch a figure.</a:t>
             </a:r>
           </a:p>
         </p:txBody>

</xml_diff>

<commit_message>
v10: rewrite the swimlane / workflow / one-pager decks; retire the enforcement page
- Tactical_Swimlane, Tactical_Workflow, Tactical_Workflow_OnePager (PPTX + PDF)
  rewritten for the v10 pass-through-to-AI flow: paste tactical text + docs -> set
  policy -> Analyse (engine computes FACTS) -> one self-contained prompt -> AI Model
  writes the narrative (or copy to any AI model) -> deck. Drops the Sort/classify/
  confirm/watchlist/Apply/enforcement-tier content. Model-agnostic ("AI Model").
- Retire the enforcement-tier page (tactical_enforcement_print_build.py + SVGs +
  note) and the combined tactical_flow_and_enforcement_v3 PDFs — the tier concept no
  longer exists in v10 (numbers stay deterministic; the AI only writes prose).

Co-Authored-By: Claude Opus 4.8 <noreply@anthropic.com>
</commit_message>
<xml_diff>
--- a/Tactical_Swimlane.pptx
+++ b/Tactical_Swimlane.pptx
@@ -3135,7 +3135,7 @@
                 </a:solidFill>
                 <a:latin typeface="Calibri"/>
               </a:rPr>
-              <a:t>MERIDIAN FAMILY OFFICE COPILOT · v8</a:t>
+              <a:t>MERIDIAN FAMILY OFFICE COPILOT · v10</a:t>
             </a:r>
           </a:p>
         </p:txBody>
@@ -3149,7 +3149,7 @@
         <p:spPr>
           <a:xfrm>
             <a:off x="731520" y="841248"/>
-            <a:ext cx="10698480" cy="822960"/>
+            <a:ext cx="10881360" cy="822960"/>
           </a:xfrm>
           <a:prstGeom prst="rect">
             <a:avLst/>
@@ -3172,13 +3172,13 @@
               </a:spcAft>
             </a:pPr>
             <a:r>
-              <a:rPr sz="2700" b="1">
+              <a:rPr sz="2600" b="1">
                 <a:solidFill>
                   <a:srgbClr val="1E2A56"/>
                 </a:solidFill>
                 <a:latin typeface="Georgia"/>
               </a:rPr>
-              <a:t>Does “Confirm items” fill your Allocations &amp; Limits?</a:t>
+              <a:t>How do the client’s tactical instructions reach the proposal?</a:t>
             </a:r>
           </a:p>
         </p:txBody>
@@ -3254,7 +3254,7 @@
                 </a:solidFill>
                 <a:latin typeface="Calibri"/>
               </a:rPr>
-              <a:t>Confirm items</a:t>
+              <a:t>Pass through — verbatim</a:t>
             </a:r>
             <a:r>
               <a:rPr sz="1200" b="0">
@@ -3263,7 +3263,7 @@
                 </a:solidFill>
                 <a:latin typeface="Calibri"/>
               </a:rPr>
-              <a:t>   — commits the interpreted instructions</a:t>
+              <a:t>   — no sorting, no classifying</a:t>
             </a:r>
           </a:p>
           <a:p>
@@ -3285,7 +3285,7 @@
                 </a:solidFill>
                 <a:latin typeface="Calibri"/>
               </a:rPr>
-              <a:t>Produces a 📡 monitoring watchlist (triggers) and guidance folded into the proposal. It writes into NO field.</a:t>
+              <a:t>The client’s tactical text goes straight into the prompt, unedited — together with the intake parameters, the parsed holdings + statement source, and the research / other documents in full.</a:t>
             </a:r>
           </a:p>
         </p:txBody>
@@ -3361,7 +3361,7 @@
                 </a:solidFill>
                 <a:latin typeface="Calibri"/>
               </a:rPr>
-              <a:t>Apply to allocation targets</a:t>
+              <a:t>One self-contained prompt</a:t>
             </a:r>
             <a:r>
               <a:rPr sz="1200" b="0">
@@ -3370,7 +3370,7 @@
                 </a:solidFill>
                 <a:latin typeface="Calibri"/>
               </a:rPr>
-              <a:t>   — the second, separate click</a:t>
+              <a:t>   — the transparency surface</a:t>
             </a:r>
           </a:p>
           <a:p>
@@ -3392,7 +3392,7 @@
                 </a:solidFill>
                 <a:latin typeface="Calibri"/>
               </a:rPr>
-              <a:t>The ONLY action that fills the allocation sleeves. Appears only if the client stated target weights (“Gold ETF: 20%”). You still verify and adjust.</a:t>
+              <a:t>Shown on the Proposal page — editable, copyable, downloadable. Paste it into ANY AI model to reproduce the proposal and compare outputs. Generate in-app runs the live AI model.</a:t>
             </a:r>
           </a:p>
         </p:txBody>
@@ -3414,11 +3414,11 @@
             </a:avLst>
           </a:prstGeom>
           <a:solidFill>
-            <a:srgbClr val="FFFFFF"/>
+            <a:srgbClr val="E6F1EB"/>
           </a:solidFill>
           <a:ln w="19050">
             <a:solidFill>
-              <a:srgbClr val="C8CDDD"/>
+              <a:srgbClr val="2F6F57"/>
             </a:solidFill>
           </a:ln>
           <a:effectLst/>
@@ -3455,29 +3455,29 @@
             <a:r>
               <a:rPr sz="1500" b="1">
                 <a:solidFill>
+                  <a:srgbClr val="2F6F57"/>
+                </a:solidFill>
+                <a:latin typeface="Calibri"/>
+              </a:rPr>
+              <a:t>3.  </a:t>
+            </a:r>
+            <a:r>
+              <a:rPr sz="1500" b="1">
+                <a:solidFill>
+                  <a:srgbClr val="2F6F57"/>
+                </a:solidFill>
+                <a:latin typeface="Calibri"/>
+              </a:rPr>
+              <a:t>Numbers stay deterministic</a:t>
+            </a:r>
+            <a:r>
+              <a:rPr sz="1200" b="0">
+                <a:solidFill>
                   <a:srgbClr val="47517A"/>
                 </a:solidFill>
                 <a:latin typeface="Calibri"/>
               </a:rPr>
-              <a:t>3.  </a:t>
-            </a:r>
-            <a:r>
-              <a:rPr sz="1500" b="1">
-                <a:solidFill>
-                  <a:srgbClr val="47517A"/>
-                </a:solidFill>
-                <a:latin typeface="Calibri"/>
-              </a:rPr>
-              <a:t>Limits</a:t>
-            </a:r>
-            <a:r>
-              <a:rPr sz="1200" b="0">
-                <a:solidFill>
-                  <a:srgbClr val="47517A"/>
-                </a:solidFill>
-                <a:latin typeface="Calibri"/>
-              </a:rPr>
-              <a:t>   — band tolerance · liquidity · FX · position caps</a:t>
+              <a:t>   — the guardrail</a:t>
             </a:r>
           </a:p>
           <a:p>
@@ -3499,7 +3499,7 @@
                 </a:solidFill>
                 <a:latin typeface="Calibri"/>
               </a:rPr>
-              <a:t>Always MANUAL — never extracted from the instructions or auto-filled.</a:t>
+              <a:t>Every figure is computed by the engine (the FACTS block). The AI writes prose only; qualitative claims from the documents are context, not independently verified.</a:t>
             </a:r>
           </a:p>
         </p:txBody>
@@ -3564,7 +3564,7 @@
                 </a:solidFill>
                 <a:latin typeface="Calibri"/>
               </a:rPr>
-              <a:t>Order, Analyse &amp; the v8 exception:  </a:t>
+              <a:t>What changed in v10:  </a:t>
             </a:r>
             <a:r>
               <a:rPr sz="1150" b="0">
@@ -3573,7 +3573,7 @@
                 </a:solidFill>
                 <a:latin typeface="Calibri"/>
               </a:rPr>
-              <a:t>Set the mandate / risk / allocations first, then Analyse — so the first read reflects the policy. Confirm still fills no field; the one exception is a 🔒 enforced price trigger (e.g. “gold below $4,000”), which gates a rebalance buy at Analyse using a sourced live price — it can flag or hold a trade, never invent one.</a:t>
+              <a:t>the copilot no longer sorts instructions into typed items, tags enforcement tiers, or gates a trade on a price trigger. It hands the raw inputs to the AI Model in one prompt and lets it analyse them — while the engine still computes every number, so nothing is invented. The UI is model-agnostic: it always reads “AI Model”.</a:t>
             </a:r>
           </a:p>
         </p:txBody>
@@ -3642,7 +3642,7 @@
                 </a:solidFill>
                 <a:latin typeface="Calibri"/>
               </a:rPr>
-              <a:t>MERIDIAN FAMILY OFFICE COPILOT · v8 · PROCESS</a:t>
+              <a:t>MERIDIAN FAMILY OFFICE COPILOT · v10 · PROCESS</a:t>
             </a:r>
           </a:p>
         </p:txBody>
@@ -3745,7 +3745,7 @@
         <p:spPr>
           <a:xfrm>
             <a:off x="1234440" y="1371600"/>
-            <a:ext cx="2286000" cy="347472"/>
+            <a:ext cx="2468880" cy="347472"/>
           </a:xfrm>
           <a:prstGeom prst="roundRect">
             <a:avLst>
@@ -3799,7 +3799,7 @@
               <a:t>A  </a:t>
             </a:r>
             <a:r>
-              <a:rPr sz="1150" b="1">
+              <a:rPr sz="1100" b="1">
                 <a:solidFill>
                   <a:srgbClr val="FFFFFF"/>
                 </a:solidFill>
@@ -3818,8 +3818,8 @@
         </p:nvSpPr>
         <p:spPr>
           <a:xfrm>
-            <a:off x="3520440" y="1371600"/>
-            <a:ext cx="4261104" cy="347472"/>
+            <a:off x="3703320" y="1371600"/>
+            <a:ext cx="2194560" cy="347472"/>
           </a:xfrm>
           <a:prstGeom prst="roundRect">
             <a:avLst>
@@ -3873,13 +3873,13 @@
               <a:t>B  </a:t>
             </a:r>
             <a:r>
-              <a:rPr sz="1150" b="1">
+              <a:rPr sz="1100" b="1">
                 <a:solidFill>
                   <a:srgbClr val="FFFFFF"/>
                 </a:solidFill>
                 <a:latin typeface="Calibri"/>
               </a:rPr>
-              <a:t>Capture tactical instructions</a:t>
+              <a:t>Capture inputs</a:t>
             </a:r>
           </a:p>
         </p:txBody>
@@ -3892,8 +3892,8 @@
         </p:nvSpPr>
         <p:spPr>
           <a:xfrm>
-            <a:off x="7781544" y="1371600"/>
-            <a:ext cx="1847088" cy="347472"/>
+            <a:off x="5897880" y="1371600"/>
+            <a:ext cx="2514600" cy="347472"/>
           </a:xfrm>
           <a:prstGeom prst="roundRect">
             <a:avLst>
@@ -3947,13 +3947,13 @@
               <a:t>C  </a:t>
             </a:r>
             <a:r>
-              <a:rPr sz="1150" b="1">
+              <a:rPr sz="1100" b="1">
                 <a:solidFill>
                   <a:srgbClr val="FFFFFF"/>
                 </a:solidFill>
                 <a:latin typeface="Calibri"/>
               </a:rPr>
-              <a:t>Analyse the statements</a:t>
+              <a:t>Compute · deterministic</a:t>
             </a:r>
           </a:p>
         </p:txBody>
@@ -3966,8 +3966,8 @@
         </p:nvSpPr>
         <p:spPr>
           <a:xfrm>
-            <a:off x="9628632" y="1371600"/>
-            <a:ext cx="2258568" cy="347472"/>
+            <a:off x="8412480" y="1371600"/>
+            <a:ext cx="3474720" cy="347472"/>
           </a:xfrm>
           <a:prstGeom prst="roundRect">
             <a:avLst>
@@ -4021,13 +4021,13 @@
               <a:t>D  </a:t>
             </a:r>
             <a:r>
-              <a:rPr sz="1150" b="1">
+              <a:rPr sz="1100" b="1">
                 <a:solidFill>
                   <a:srgbClr val="FFFFFF"/>
                 </a:solidFill>
                 <a:latin typeface="Calibri"/>
               </a:rPr>
-              <a:t>Review &amp; generate</a:t>
+              <a:t>Assemble → generate → deliver</a:t>
             </a:r>
           </a:p>
         </p:txBody>
@@ -4439,8 +4439,8 @@
         </p:nvSpPr>
         <p:spPr>
           <a:xfrm>
-            <a:off x="3630168" y="1938528"/>
-            <a:ext cx="2556662" cy="713231"/>
+            <a:off x="3813048" y="1938528"/>
+            <a:ext cx="1975104" cy="713231"/>
           </a:xfrm>
           <a:prstGeom prst="roundRect">
             <a:avLst>
@@ -4493,7 +4493,7 @@
                 </a:solidFill>
                 <a:latin typeface="Calibri"/>
               </a:rPr>
-              <a:t>Gives instructions (plain language)</a:t>
+              <a:t>Gives instructions + documents</a:t>
             </a:r>
           </a:p>
           <a:p>
@@ -4515,7 +4515,7 @@
                 </a:solidFill>
                 <a:latin typeface="Calibri"/>
               </a:rPr>
-              <a:t>“gold below $4,000”, “Gold ETF: 20%”…</a:t>
+              <a:t>“gold below $4,000” · statements · research</a:t>
             </a:r>
           </a:p>
         </p:txBody>
@@ -4528,97 +4528,8 @@
         </p:nvSpPr>
         <p:spPr>
           <a:xfrm>
-            <a:off x="7891271" y="1938528"/>
-            <a:ext cx="1627632" cy="713231"/>
-          </a:xfrm>
-          <a:prstGeom prst="roundRect">
-            <a:avLst>
-              <a:gd name="adj" fmla="val 10000"/>
-            </a:avLst>
-          </a:prstGeom>
-          <a:solidFill>
-            <a:srgbClr val="FFFFFF"/>
-          </a:solidFill>
-          <a:ln w="12700">
-            <a:solidFill>
-              <a:srgbClr val="9CA8CE"/>
-            </a:solidFill>
-          </a:ln>
-          <a:effectLst/>
-        </p:spPr>
-        <p:style>
-          <a:lnRef idx="1">
-            <a:schemeClr val="accent1"/>
-          </a:lnRef>
-          <a:fillRef idx="3">
-            <a:schemeClr val="accent1"/>
-          </a:fillRef>
-          <a:effectRef idx="2">
-            <a:schemeClr val="accent1"/>
-          </a:effectRef>
-          <a:fontRef idx="minor">
-            <a:schemeClr val="lt1"/>
-          </a:fontRef>
-        </p:style>
-        <p:txBody>
-          <a:bodyPr rtlCol="0" anchor="ctr" wrap="square" lIns="73152" rIns="64008"/>
-          <a:lstStyle/>
-          <a:p>
-            <a:pPr algn="l">
-              <a:lnSpc>
-                <a:spcPct val="100000"/>
-              </a:lnSpc>
-              <a:spcBef>
-                <a:spcPts val="0"/>
-              </a:spcBef>
-              <a:spcAft>
-                <a:spcPts val="0"/>
-              </a:spcAft>
-            </a:pPr>
-            <a:r>
-              <a:rPr sz="1050" b="1">
-                <a:solidFill>
-                  <a:srgbClr val="16203C"/>
-                </a:solidFill>
-                <a:latin typeface="Calibri"/>
-              </a:rPr>
-              <a:t>Hands over statements</a:t>
-            </a:r>
-          </a:p>
-          <a:p>
-            <a:pPr algn="l">
-              <a:lnSpc>
-                <a:spcPct val="102000"/>
-              </a:lnSpc>
-              <a:spcBef>
-                <a:spcPts val="200"/>
-              </a:spcBef>
-              <a:spcAft>
-                <a:spcPts val="0"/>
-              </a:spcAft>
-            </a:pPr>
-            <a:r>
-              <a:rPr sz="800" b="0">
-                <a:solidFill>
-                  <a:srgbClr val="47517A"/>
-                </a:solidFill>
-                <a:latin typeface="Calibri"/>
-              </a:rPr>
-              <a:t>INPUT</a:t>
-            </a:r>
-          </a:p>
-        </p:txBody>
-      </p:sp>
-      <p:sp>
-        <p:nvSpPr>
-          <p:cNvPr id="17" name="Rounded Rectangle 16"/>
-          <p:cNvSpPr/>
-          <p:nvPr/>
-        </p:nvSpPr>
-        <p:spPr>
-          <a:xfrm>
             <a:off x="1344168" y="3108960"/>
-            <a:ext cx="2066543" cy="932688"/>
+            <a:ext cx="2249424" cy="932688"/>
           </a:xfrm>
           <a:prstGeom prst="roundRect">
             <a:avLst>
@@ -4687,14 +4598,14 @@
       </p:sp>
       <p:sp>
         <p:nvSpPr>
-          <p:cNvPr id="18" name="Rounded Rectangle 17"/>
+          <p:cNvPr id="17" name="Rounded Rectangle 16"/>
           <p:cNvSpPr/>
           <p:nvPr/>
         </p:nvSpPr>
         <p:spPr>
           <a:xfrm>
             <a:off x="1344168" y="4114800"/>
-            <a:ext cx="2066543" cy="932688"/>
+            <a:ext cx="2249424" cy="932688"/>
           </a:xfrm>
           <a:prstGeom prst="roundRect">
             <a:avLst>
@@ -4778,21 +4689,21 @@
                 </a:solidFill>
                 <a:latin typeface="Calibri"/>
               </a:rPr>
-              <a:t>limits manual · sleeves can be pre-filled by 6</a:t>
-            </a:r>
-          </a:p>
-        </p:txBody>
-      </p:sp>
-      <p:sp>
-        <p:nvSpPr>
-          <p:cNvPr id="19" name="Rounded Rectangle 18"/>
+              <a:t>limits always manual</a:t>
+            </a:r>
+          </a:p>
+        </p:txBody>
+      </p:sp>
+      <p:sp>
+        <p:nvSpPr>
+          <p:cNvPr id="18" name="Rounded Rectangle 17"/>
           <p:cNvSpPr/>
           <p:nvPr/>
         </p:nvSpPr>
         <p:spPr>
           <a:xfrm>
-            <a:off x="3611880" y="2999232"/>
-            <a:ext cx="1965960" cy="658368"/>
+            <a:off x="3813048" y="3438144"/>
+            <a:ext cx="1975104" cy="1188720"/>
           </a:xfrm>
           <a:prstGeom prst="roundRect">
             <a:avLst>
@@ -4839,7 +4750,7 @@
               </a:spcAft>
             </a:pPr>
             <a:r>
-              <a:rPr sz="950" b="1">
+              <a:rPr sz="1000" b="1">
                 <a:solidFill>
                   <a:srgbClr val="9C7422"/>
                 </a:solidFill>
@@ -4848,27 +4759,49 @@
               <a:t>3 · </a:t>
             </a:r>
             <a:r>
-              <a:rPr sz="950" b="1">
+              <a:rPr sz="1000" b="1">
                 <a:solidFill>
                   <a:srgbClr val="16203C"/>
                 </a:solidFill>
                 <a:latin typeface="Calibri"/>
               </a:rPr>
-              <a:t>Paste → Sort into items</a:t>
-            </a:r>
-          </a:p>
-        </p:txBody>
-      </p:sp>
-      <p:sp>
-        <p:nvSpPr>
-          <p:cNvPr id="20" name="Rounded Rectangle 19"/>
+              <a:t>Paste tactical text (verbatim) + upload documents</a:t>
+            </a:r>
+          </a:p>
+          <a:p>
+            <a:pPr algn="l">
+              <a:lnSpc>
+                <a:spcPct val="102000"/>
+              </a:lnSpc>
+              <a:spcBef>
+                <a:spcPts val="200"/>
+              </a:spcBef>
+              <a:spcAft>
+                <a:spcPts val="0"/>
+              </a:spcAft>
+            </a:pPr>
+            <a:r>
+              <a:rPr sz="800" b="0">
+                <a:solidFill>
+                  <a:srgbClr val="47517A"/>
+                </a:solidFill>
+                <a:latin typeface="Calibri"/>
+              </a:rPr>
+              <a:t>the client’s words, unedited</a:t>
+            </a:r>
+          </a:p>
+        </p:txBody>
+      </p:sp>
+      <p:sp>
+        <p:nvSpPr>
+          <p:cNvPr id="19" name="Rounded Rectangle 18"/>
           <p:cNvSpPr/>
           <p:nvPr/>
         </p:nvSpPr>
         <p:spPr>
           <a:xfrm>
-            <a:off x="5724144" y="2999232"/>
-            <a:ext cx="1965960" cy="658368"/>
+            <a:off x="6007608" y="3575304"/>
+            <a:ext cx="2295144" cy="868680"/>
           </a:xfrm>
           <a:prstGeom prst="roundRect">
             <a:avLst>
@@ -4915,7 +4848,7 @@
               </a:spcAft>
             </a:pPr>
             <a:r>
-              <a:rPr sz="950" b="1">
+              <a:rPr sz="1000" b="1">
                 <a:solidFill>
                   <a:srgbClr val="9C7422"/>
                 </a:solidFill>
@@ -4924,103 +4857,49 @@
               <a:t>4 · </a:t>
             </a:r>
             <a:r>
-              <a:rPr sz="950" b="1">
+              <a:rPr sz="1000" b="1">
                 <a:solidFill>
                   <a:srgbClr val="16203C"/>
                 </a:solidFill>
                 <a:latin typeface="Calibri"/>
               </a:rPr>
-              <a:t>Review: Keep · edit · notes</a:t>
-            </a:r>
-          </a:p>
-        </p:txBody>
-      </p:sp>
-      <p:sp>
-        <p:nvSpPr>
-          <p:cNvPr id="21" name="Rounded Rectangle 20"/>
+              <a:t>Analyse ▸</a:t>
+            </a:r>
+          </a:p>
+          <a:p>
+            <a:pPr algn="l">
+              <a:lnSpc>
+                <a:spcPct val="102000"/>
+              </a:lnSpc>
+              <a:spcBef>
+                <a:spcPts val="200"/>
+              </a:spcBef>
+              <a:spcAft>
+                <a:spcPts val="0"/>
+              </a:spcAft>
+            </a:pPr>
+            <a:r>
+              <a:rPr sz="830" b="0">
+                <a:solidFill>
+                  <a:srgbClr val="47517A"/>
+                </a:solidFill>
+                <a:latin typeface="Calibri"/>
+              </a:rPr>
+              <a:t>after the policy above is set</a:t>
+            </a:r>
+          </a:p>
+        </p:txBody>
+      </p:sp>
+      <p:sp>
+        <p:nvSpPr>
+          <p:cNvPr id="20" name="Rounded Rectangle 19"/>
           <p:cNvSpPr/>
           <p:nvPr/>
         </p:nvSpPr>
         <p:spPr>
           <a:xfrm>
-            <a:off x="3611880" y="3712464"/>
-            <a:ext cx="4078224" cy="457200"/>
-          </a:xfrm>
-          <a:prstGeom prst="roundRect">
-            <a:avLst>
-              <a:gd name="adj" fmla="val 12000"/>
-            </a:avLst>
-          </a:prstGeom>
-          <a:solidFill>
-            <a:srgbClr val="FBE6D2"/>
-          </a:solidFill>
-          <a:ln w="15875">
-            <a:solidFill>
-              <a:srgbClr val="B06A17"/>
-            </a:solidFill>
-          </a:ln>
-          <a:effectLst/>
-        </p:spPr>
-        <p:style>
-          <a:lnRef idx="1">
-            <a:schemeClr val="accent1"/>
-          </a:lnRef>
-          <a:fillRef idx="3">
-            <a:schemeClr val="accent1"/>
-          </a:fillRef>
-          <a:effectRef idx="2">
-            <a:schemeClr val="accent1"/>
-          </a:effectRef>
-          <a:fontRef idx="minor">
-            <a:schemeClr val="lt1"/>
-          </a:fontRef>
-        </p:style>
-        <p:txBody>
-          <a:bodyPr rtlCol="0" anchor="ctr" wrap="square" lIns="73152" rIns="64008"/>
-          <a:lstStyle/>
-          <a:p>
-            <a:pPr algn="ctr">
-              <a:lnSpc>
-                <a:spcPct val="100000"/>
-              </a:lnSpc>
-              <a:spcBef>
-                <a:spcPts val="0"/>
-              </a:spcBef>
-              <a:spcAft>
-                <a:spcPts val="0"/>
-              </a:spcAft>
-            </a:pPr>
-            <a:r>
-              <a:rPr sz="950" b="1">
-                <a:solidFill>
-                  <a:srgbClr val="B06A17"/>
-                </a:solidFill>
-                <a:latin typeface="Calibri"/>
-              </a:rPr>
-              <a:t>◇ needs-clarification?  </a:t>
-            </a:r>
-            <a:r>
-              <a:rPr sz="900" b="0">
-                <a:solidFill>
-                  <a:srgbClr val="47517A"/>
-                </a:solidFill>
-                <a:latin typeface="Calibri"/>
-              </a:rPr>
-              <a:t>Yes → ask client ⟲   ·   No ↓</a:t>
-            </a:r>
-          </a:p>
-        </p:txBody>
-      </p:sp>
-      <p:sp>
-        <p:nvSpPr>
-          <p:cNvPr id="22" name="Rounded Rectangle 21"/>
-          <p:cNvSpPr/>
-          <p:nvPr/>
-        </p:nvSpPr>
-        <p:spPr>
-          <a:xfrm>
-            <a:off x="3611880" y="4242816"/>
-            <a:ext cx="1965960" cy="786384"/>
+            <a:off x="8522208" y="3035808"/>
+            <a:ext cx="3255263" cy="603504"/>
           </a:xfrm>
           <a:prstGeom prst="roundRect">
             <a:avLst>
@@ -5067,7 +4946,7 @@
               </a:spcAft>
             </a:pPr>
             <a:r>
-              <a:rPr sz="950" b="1">
+              <a:rPr sz="1000" b="1">
                 <a:solidFill>
                   <a:srgbClr val="9C7422"/>
                 </a:solidFill>
@@ -5076,49 +4955,27 @@
               <a:t>5 · </a:t>
             </a:r>
             <a:r>
-              <a:rPr sz="950" b="1">
+              <a:rPr sz="1000" b="1">
                 <a:solidFill>
                   <a:srgbClr val="16203C"/>
                 </a:solidFill>
                 <a:latin typeface="Calibri"/>
               </a:rPr>
-              <a:t>Confirm items</a:t>
-            </a:r>
-          </a:p>
-          <a:p>
-            <a:pPr algn="l">
-              <a:lnSpc>
-                <a:spcPct val="102000"/>
-              </a:lnSpc>
-              <a:spcBef>
-                <a:spcPts val="200"/>
-              </a:spcBef>
-              <a:spcAft>
-                <a:spcPts val="0"/>
-              </a:spcAft>
-            </a:pPr>
-            <a:r>
-              <a:rPr sz="780" b="0">
-                <a:solidFill>
-                  <a:srgbClr val="47517A"/>
-                </a:solidFill>
-                <a:latin typeface="Calibri"/>
-              </a:rPr>
-              <a:t>commits guidance + watchlist · fills NO fields</a:t>
-            </a:r>
-          </a:p>
-        </p:txBody>
-      </p:sp>
-      <p:sp>
-        <p:nvSpPr>
-          <p:cNvPr id="23" name="Rounded Rectangle 22"/>
+              <a:t>Review the assembled prompt</a:t>
+            </a:r>
+          </a:p>
+        </p:txBody>
+      </p:sp>
+      <p:sp>
+        <p:nvSpPr>
+          <p:cNvPr id="21" name="Rounded Rectangle 20"/>
           <p:cNvSpPr/>
           <p:nvPr/>
         </p:nvSpPr>
         <p:spPr>
           <a:xfrm>
-            <a:off x="5724144" y="4242816"/>
-            <a:ext cx="1965960" cy="786384"/>
+            <a:off x="8522208" y="3712464"/>
+            <a:ext cx="3255263" cy="603504"/>
           </a:xfrm>
           <a:prstGeom prst="roundRect">
             <a:avLst>
@@ -5165,7 +5022,7 @@
               </a:spcAft>
             </a:pPr>
             <a:r>
-              <a:rPr sz="950" b="1">
+              <a:rPr sz="1000" b="1">
                 <a:solidFill>
                   <a:srgbClr val="9C7422"/>
                 </a:solidFill>
@@ -5174,49 +5031,27 @@
               <a:t>6 · </a:t>
             </a:r>
             <a:r>
-              <a:rPr sz="950" b="1">
+              <a:rPr sz="1000" b="1">
                 <a:solidFill>
                   <a:srgbClr val="16203C"/>
                 </a:solidFill>
                 <a:latin typeface="Calibri"/>
               </a:rPr>
-              <a:t>Apply to allocation targets</a:t>
-            </a:r>
-          </a:p>
-          <a:p>
-            <a:pPr algn="l">
-              <a:lnSpc>
-                <a:spcPct val="102000"/>
-              </a:lnSpc>
-              <a:spcBef>
-                <a:spcPts val="200"/>
-              </a:spcBef>
-              <a:spcAft>
-                <a:spcPts val="0"/>
-              </a:spcAft>
-            </a:pPr>
-            <a:r>
-              <a:rPr sz="780" b="0">
-                <a:solidFill>
-                  <a:srgbClr val="47517A"/>
-                </a:solidFill>
-                <a:latin typeface="Calibri"/>
-              </a:rPr>
-              <a:t>only action that fills sleeves · optional · ⤶ fills 2</a:t>
-            </a:r>
-          </a:p>
-        </p:txBody>
-      </p:sp>
-      <p:sp>
-        <p:nvSpPr>
-          <p:cNvPr id="24" name="Rounded Rectangle 23"/>
+              <a:t>Generate — or copy to any AI model</a:t>
+            </a:r>
+          </a:p>
+        </p:txBody>
+      </p:sp>
+      <p:sp>
+        <p:nvSpPr>
+          <p:cNvPr id="22" name="Rounded Rectangle 21"/>
           <p:cNvSpPr/>
           <p:nvPr/>
         </p:nvSpPr>
         <p:spPr>
           <a:xfrm>
-            <a:off x="7891271" y="3575304"/>
-            <a:ext cx="1627632" cy="868680"/>
+            <a:off x="8522208" y="4389120"/>
+            <a:ext cx="3255263" cy="603504"/>
           </a:xfrm>
           <a:prstGeom prst="roundRect">
             <a:avLst>
@@ -5278,7 +5113,7 @@
                 </a:solidFill>
                 <a:latin typeface="Calibri"/>
               </a:rPr>
-              <a:t>Upload → Analyse ▸</a:t>
+              <a:t>Review &amp; download the deck</a:t>
             </a:r>
           </a:p>
           <a:p>
@@ -5300,195 +5135,21 @@
                 </a:solidFill>
                 <a:latin typeface="Calibri"/>
               </a:rPr>
-              <a:t>after policy above is set · then live</a:t>
-            </a:r>
-          </a:p>
-        </p:txBody>
-      </p:sp>
-      <p:sp>
-        <p:nvSpPr>
-          <p:cNvPr id="25" name="Rounded Rectangle 24"/>
+              <a:t>PPTX / PDF</a:t>
+            </a:r>
+          </a:p>
+        </p:txBody>
+      </p:sp>
+      <p:sp>
+        <p:nvSpPr>
+          <p:cNvPr id="23" name="Rounded Rectangle 22"/>
           <p:cNvSpPr/>
           <p:nvPr/>
         </p:nvSpPr>
         <p:spPr>
           <a:xfrm>
-            <a:off x="9738359" y="3108960"/>
-            <a:ext cx="2039112" cy="932688"/>
-          </a:xfrm>
-          <a:prstGeom prst="roundRect">
-            <a:avLst>
-              <a:gd name="adj" fmla="val 10000"/>
-            </a:avLst>
-          </a:prstGeom>
-          <a:solidFill>
-            <a:srgbClr val="FFFFFF"/>
-          </a:solidFill>
-          <a:ln w="15875">
-            <a:solidFill>
-              <a:srgbClr val="B0872A"/>
-            </a:solidFill>
-          </a:ln>
-          <a:effectLst/>
-        </p:spPr>
-        <p:style>
-          <a:lnRef idx="1">
-            <a:schemeClr val="accent1"/>
-          </a:lnRef>
-          <a:fillRef idx="3">
-            <a:schemeClr val="accent1"/>
-          </a:fillRef>
-          <a:effectRef idx="2">
-            <a:schemeClr val="accent1"/>
-          </a:effectRef>
-          <a:fontRef idx="minor">
-            <a:schemeClr val="lt1"/>
-          </a:fontRef>
-        </p:style>
-        <p:txBody>
-          <a:bodyPr rtlCol="0" anchor="ctr" wrap="square" lIns="73152" rIns="64008"/>
-          <a:lstStyle/>
-          <a:p>
-            <a:pPr algn="l">
-              <a:lnSpc>
-                <a:spcPct val="100000"/>
-              </a:lnSpc>
-              <a:spcBef>
-                <a:spcPts val="0"/>
-              </a:spcBef>
-              <a:spcAft>
-                <a:spcPts val="0"/>
-              </a:spcAft>
-            </a:pPr>
-            <a:r>
-              <a:rPr sz="1000" b="1">
-                <a:solidFill>
-                  <a:srgbClr val="9C7422"/>
-                </a:solidFill>
-                <a:latin typeface="Calibri"/>
-              </a:rPr>
-              <a:t>8 · </a:t>
-            </a:r>
-            <a:r>
-              <a:rPr sz="1000" b="1">
-                <a:solidFill>
-                  <a:srgbClr val="16203C"/>
-                </a:solidFill>
-                <a:latin typeface="Calibri"/>
-              </a:rPr>
-              <a:t>Review Overview / Suitability</a:t>
-            </a:r>
-          </a:p>
-        </p:txBody>
-      </p:sp>
-      <p:sp>
-        <p:nvSpPr>
-          <p:cNvPr id="26" name="Rounded Rectangle 25"/>
-          <p:cNvSpPr/>
-          <p:nvPr/>
-        </p:nvSpPr>
-        <p:spPr>
-          <a:xfrm>
-            <a:off x="9738359" y="4114800"/>
-            <a:ext cx="2039112" cy="932688"/>
-          </a:xfrm>
-          <a:prstGeom prst="roundRect">
-            <a:avLst>
-              <a:gd name="adj" fmla="val 10000"/>
-            </a:avLst>
-          </a:prstGeom>
-          <a:solidFill>
-            <a:srgbClr val="FFFFFF"/>
-          </a:solidFill>
-          <a:ln w="15875">
-            <a:solidFill>
-              <a:srgbClr val="B0872A"/>
-            </a:solidFill>
-          </a:ln>
-          <a:effectLst/>
-        </p:spPr>
-        <p:style>
-          <a:lnRef idx="1">
-            <a:schemeClr val="accent1"/>
-          </a:lnRef>
-          <a:fillRef idx="3">
-            <a:schemeClr val="accent1"/>
-          </a:fillRef>
-          <a:effectRef idx="2">
-            <a:schemeClr val="accent1"/>
-          </a:effectRef>
-          <a:fontRef idx="minor">
-            <a:schemeClr val="lt1"/>
-          </a:fontRef>
-        </p:style>
-        <p:txBody>
-          <a:bodyPr rtlCol="0" anchor="ctr" wrap="square" lIns="73152" rIns="64008"/>
-          <a:lstStyle/>
-          <a:p>
-            <a:pPr algn="l">
-              <a:lnSpc>
-                <a:spcPct val="100000"/>
-              </a:lnSpc>
-              <a:spcBef>
-                <a:spcPts val="0"/>
-              </a:spcBef>
-              <a:spcAft>
-                <a:spcPts val="0"/>
-              </a:spcAft>
-            </a:pPr>
-            <a:r>
-              <a:rPr sz="1000" b="1">
-                <a:solidFill>
-                  <a:srgbClr val="9C7422"/>
-                </a:solidFill>
-                <a:latin typeface="Calibri"/>
-              </a:rPr>
-              <a:t>9 · </a:t>
-            </a:r>
-            <a:r>
-              <a:rPr sz="1000" b="1">
-                <a:solidFill>
-                  <a:srgbClr val="16203C"/>
-                </a:solidFill>
-                <a:latin typeface="Calibri"/>
-              </a:rPr>
-              <a:t>Open Proposal → Generate deck</a:t>
-            </a:r>
-          </a:p>
-          <a:p>
-            <a:pPr algn="l">
-              <a:lnSpc>
-                <a:spcPct val="102000"/>
-              </a:lnSpc>
-              <a:spcBef>
-                <a:spcPts val="200"/>
-              </a:spcBef>
-              <a:spcAft>
-                <a:spcPts val="0"/>
-              </a:spcAft>
-            </a:pPr>
-            <a:r>
-              <a:rPr sz="830" b="0">
-                <a:solidFill>
-                  <a:srgbClr val="47517A"/>
-                </a:solidFill>
-                <a:latin typeface="Calibri"/>
-              </a:rPr>
-              <a:t>PPTX / PDF</a:t>
-            </a:r>
-          </a:p>
-        </p:txBody>
-      </p:sp>
-      <p:sp>
-        <p:nvSpPr>
-          <p:cNvPr id="27" name="Rounded Rectangle 26"/>
-          <p:cNvSpPr/>
-          <p:nvPr/>
-        </p:nvSpPr>
-        <p:spPr>
-          <a:xfrm>
-            <a:off x="3611880" y="5376672"/>
-            <a:ext cx="1975104" cy="1005840"/>
+            <a:off x="6007608" y="5321807"/>
+            <a:ext cx="2295144" cy="530352"/>
           </a:xfrm>
           <a:prstGeom prst="roundRect">
             <a:avLst>
@@ -5542,7 +5203,7 @@
                 </a:solidFill>
                 <a:latin typeface="Calibri"/>
               </a:rPr>
-              <a:t>⚙ AUTO</a:t>
+              <a:t>⚙ ON ANALYSE</a:t>
             </a:r>
           </a:p>
           <a:p>
@@ -5564,43 +5225,21 @@
                 </a:solidFill>
                 <a:latin typeface="Calibri"/>
               </a:rPr>
-              <a:t>Classify + tag tier</a:t>
-            </a:r>
-          </a:p>
-          <a:p>
-            <a:pPr algn="l">
-              <a:lnSpc>
-                <a:spcPct val="100000"/>
-              </a:lnSpc>
-              <a:spcBef>
-                <a:spcPts val="200"/>
-              </a:spcBef>
-              <a:spcAft>
-                <a:spcPts val="0"/>
-              </a:spcAft>
-            </a:pPr>
-            <a:r>
-              <a:rPr sz="830" b="0">
-                <a:solidFill>
-                  <a:srgbClr val="47517A"/>
-                </a:solidFill>
-                <a:latin typeface="Calibri"/>
-              </a:rPr>
-              <a:t>🔒 / 📡 / 📝 per item</a:t>
-            </a:r>
-          </a:p>
-        </p:txBody>
-      </p:sp>
-      <p:sp>
-        <p:nvSpPr>
-          <p:cNvPr id="28" name="Rounded Rectangle 27"/>
+              <a:t>Parse → build the book</a:t>
+            </a:r>
+          </a:p>
+        </p:txBody>
+      </p:sp>
+      <p:sp>
+        <p:nvSpPr>
+          <p:cNvPr id="24" name="Rounded Rectangle 23"/>
           <p:cNvSpPr/>
           <p:nvPr/>
         </p:nvSpPr>
         <p:spPr>
           <a:xfrm>
-            <a:off x="5715000" y="5376672"/>
-            <a:ext cx="1975104" cy="1005840"/>
+            <a:off x="6007608" y="5907024"/>
+            <a:ext cx="2295144" cy="530352"/>
           </a:xfrm>
           <a:prstGeom prst="roundRect">
             <a:avLst>
@@ -5654,7 +5293,7 @@
                 </a:solidFill>
                 <a:latin typeface="Calibri"/>
               </a:rPr>
-              <a:t>⚙ ON CONFIRM</a:t>
+              <a:t>⚙ AUTO</a:t>
             </a:r>
           </a:p>
           <a:p>
@@ -5676,7 +5315,7 @@
                 </a:solidFill>
                 <a:latin typeface="Calibri"/>
               </a:rPr>
-              <a:t>Watchlist + guidance</a:t>
+              <a:t>Compute deterministic FACTS</a:t>
             </a:r>
           </a:p>
           <a:p>
@@ -5698,21 +5337,21 @@
                 </a:solidFill>
                 <a:latin typeface="Calibri"/>
               </a:rPr>
-              <a:t>+ builds Proposed allocation</a:t>
-            </a:r>
-          </a:p>
-        </p:txBody>
-      </p:sp>
-      <p:sp>
-        <p:nvSpPr>
-          <p:cNvPr id="29" name="Rounded Rectangle 28"/>
+              <a:t>allocation · drift · suitability</a:t>
+            </a:r>
+          </a:p>
+        </p:txBody>
+      </p:sp>
+      <p:sp>
+        <p:nvSpPr>
+          <p:cNvPr id="25" name="Rounded Rectangle 24"/>
           <p:cNvSpPr/>
           <p:nvPr/>
         </p:nvSpPr>
         <p:spPr>
           <a:xfrm>
-            <a:off x="7891271" y="5321807"/>
-            <a:ext cx="1627632" cy="548640"/>
+            <a:off x="8522208" y="5468112"/>
+            <a:ext cx="1011935" cy="822960"/>
           </a:xfrm>
           <a:prstGeom prst="roundRect">
             <a:avLst>
@@ -5766,7 +5405,7 @@
                 </a:solidFill>
                 <a:latin typeface="Calibri"/>
               </a:rPr>
-              <a:t>⚙ ON ANALYSE</a:t>
+              <a:t>⚙ ASSEMBLE</a:t>
             </a:r>
           </a:p>
           <a:p>
@@ -5788,21 +5427,110 @@
                 </a:solidFill>
                 <a:latin typeface="Calibri"/>
               </a:rPr>
-              <a:t>Parse → build the book</a:t>
-            </a:r>
-          </a:p>
-        </p:txBody>
-      </p:sp>
-      <p:sp>
-        <p:nvSpPr>
-          <p:cNvPr id="30" name="Rounded Rectangle 29"/>
+              <a:t>One self-contained prompt</a:t>
+            </a:r>
+          </a:p>
+        </p:txBody>
+      </p:sp>
+      <p:sp>
+        <p:nvSpPr>
+          <p:cNvPr id="26" name="Rounded Rectangle 25"/>
           <p:cNvSpPr/>
           <p:nvPr/>
         </p:nvSpPr>
         <p:spPr>
           <a:xfrm>
-            <a:off x="7891271" y="5925312"/>
-            <a:ext cx="1627632" cy="548640"/>
+            <a:off x="9643871" y="5468112"/>
+            <a:ext cx="1011935" cy="822960"/>
+          </a:xfrm>
+          <a:prstGeom prst="roundRect">
+            <a:avLst>
+              <a:gd name="adj" fmla="val 10000"/>
+            </a:avLst>
+          </a:prstGeom>
+          <a:solidFill>
+            <a:srgbClr val="FFFFFF"/>
+          </a:solidFill>
+          <a:ln w="16510">
+            <a:solidFill>
+              <a:srgbClr val="B0872A"/>
+            </a:solidFill>
+          </a:ln>
+          <a:effectLst/>
+        </p:spPr>
+        <p:style>
+          <a:lnRef idx="1">
+            <a:schemeClr val="accent1"/>
+          </a:lnRef>
+          <a:fillRef idx="3">
+            <a:schemeClr val="accent1"/>
+          </a:fillRef>
+          <a:effectRef idx="2">
+            <a:schemeClr val="accent1"/>
+          </a:effectRef>
+          <a:fontRef idx="minor">
+            <a:schemeClr val="lt1"/>
+          </a:fontRef>
+        </p:style>
+        <p:txBody>
+          <a:bodyPr rtlCol="0" anchor="ctr" wrap="square" lIns="73152" rIns="64008"/>
+          <a:lstStyle/>
+          <a:p>
+            <a:pPr algn="l">
+              <a:lnSpc>
+                <a:spcPct val="100000"/>
+              </a:lnSpc>
+              <a:spcBef>
+                <a:spcPts val="0"/>
+              </a:spcBef>
+              <a:spcAft>
+                <a:spcPts val="0"/>
+              </a:spcAft>
+            </a:pPr>
+            <a:r>
+              <a:rPr sz="800" b="1">
+                <a:solidFill>
+                  <a:srgbClr val="9C7422"/>
+                </a:solidFill>
+                <a:latin typeface="Calibri"/>
+              </a:rPr>
+              <a:t>✨ AI MODEL</a:t>
+            </a:r>
+          </a:p>
+          <a:p>
+            <a:pPr algn="l">
+              <a:lnSpc>
+                <a:spcPct val="100000"/>
+              </a:lnSpc>
+              <a:spcBef>
+                <a:spcPts val="200"/>
+              </a:spcBef>
+              <a:spcAft>
+                <a:spcPts val="0"/>
+              </a:spcAft>
+            </a:pPr>
+            <a:r>
+              <a:rPr sz="1000" b="1">
+                <a:solidFill>
+                  <a:srgbClr val="16203C"/>
+                </a:solidFill>
+                <a:latin typeface="Calibri"/>
+              </a:rPr>
+              <a:t>Writes the narrative</a:t>
+            </a:r>
+          </a:p>
+        </p:txBody>
+      </p:sp>
+      <p:sp>
+        <p:nvSpPr>
+          <p:cNvPr id="27" name="Rounded Rectangle 26"/>
+          <p:cNvSpPr/>
+          <p:nvPr/>
+        </p:nvSpPr>
+        <p:spPr>
+          <a:xfrm>
+            <a:off x="10765535" y="5468112"/>
+            <a:ext cx="1011935" cy="822960"/>
           </a:xfrm>
           <a:prstGeom prst="roundRect">
             <a:avLst>
@@ -5856,7 +5584,7 @@
                 </a:solidFill>
                 <a:latin typeface="Calibri"/>
               </a:rPr>
-              <a:t>⚙ AUTO · LIVE</a:t>
+              <a:t>⚙ RENDER</a:t>
             </a:r>
           </a:p>
           <a:p>
@@ -5878,7 +5606,7 @@
                 </a:solidFill>
                 <a:latin typeface="Calibri"/>
               </a:rPr>
-              <a:t>Compute + apply 🔒 triggers</a:t>
+              <a:t>PPTX / PDF deck</a:t>
             </a:r>
           </a:p>
           <a:p>
@@ -5900,118 +5628,6 @@
                 </a:solidFill>
                 <a:latin typeface="Calibri"/>
               </a:rPr>
-              <a:t>gates buys vs live price</a:t>
-            </a:r>
-          </a:p>
-        </p:txBody>
-      </p:sp>
-      <p:sp>
-        <p:nvSpPr>
-          <p:cNvPr id="31" name="Rounded Rectangle 30"/>
-          <p:cNvSpPr/>
-          <p:nvPr/>
-        </p:nvSpPr>
-        <p:spPr>
-          <a:xfrm>
-            <a:off x="9738359" y="5376672"/>
-            <a:ext cx="2039112" cy="1005840"/>
-          </a:xfrm>
-          <a:prstGeom prst="roundRect">
-            <a:avLst>
-              <a:gd name="adj" fmla="val 10000"/>
-            </a:avLst>
-          </a:prstGeom>
-          <a:solidFill>
-            <a:srgbClr val="FFFFFF"/>
-          </a:solidFill>
-          <a:ln w="12700">
-            <a:solidFill>
-              <a:srgbClr val="C8CDDD"/>
-            </a:solidFill>
-            <a:prstDash val="dash"/>
-          </a:ln>
-          <a:effectLst/>
-        </p:spPr>
-        <p:style>
-          <a:lnRef idx="1">
-            <a:schemeClr val="accent1"/>
-          </a:lnRef>
-          <a:fillRef idx="3">
-            <a:schemeClr val="accent1"/>
-          </a:fillRef>
-          <a:effectRef idx="2">
-            <a:schemeClr val="accent1"/>
-          </a:effectRef>
-          <a:fontRef idx="minor">
-            <a:schemeClr val="lt1"/>
-          </a:fontRef>
-        </p:style>
-        <p:txBody>
-          <a:bodyPr rtlCol="0" anchor="ctr" wrap="square" lIns="73152" rIns="64008"/>
-          <a:lstStyle/>
-          <a:p>
-            <a:pPr algn="l">
-              <a:lnSpc>
-                <a:spcPct val="100000"/>
-              </a:lnSpc>
-              <a:spcBef>
-                <a:spcPts val="0"/>
-              </a:spcBef>
-              <a:spcAft>
-                <a:spcPts val="0"/>
-              </a:spcAft>
-            </a:pPr>
-            <a:r>
-              <a:rPr sz="800" b="1">
-                <a:solidFill>
-                  <a:srgbClr val="838CAD"/>
-                </a:solidFill>
-                <a:latin typeface="Calibri"/>
-              </a:rPr>
-              <a:t>⚙ AUTO</a:t>
-            </a:r>
-          </a:p>
-          <a:p>
-            <a:pPr algn="l">
-              <a:lnSpc>
-                <a:spcPct val="100000"/>
-              </a:lnSpc>
-              <a:spcBef>
-                <a:spcPts val="200"/>
-              </a:spcBef>
-              <a:spcAft>
-                <a:spcPts val="0"/>
-              </a:spcAft>
-            </a:pPr>
-            <a:r>
-              <a:rPr sz="1000" b="1">
-                <a:solidFill>
-                  <a:srgbClr val="47517A"/>
-                </a:solidFill>
-                <a:latin typeface="Calibri"/>
-              </a:rPr>
-              <a:t>Generate PPTX / PDF</a:t>
-            </a:r>
-          </a:p>
-          <a:p>
-            <a:pPr algn="l">
-              <a:lnSpc>
-                <a:spcPct val="100000"/>
-              </a:lnSpc>
-              <a:spcBef>
-                <a:spcPts val="200"/>
-              </a:spcBef>
-              <a:spcAft>
-                <a:spcPts val="0"/>
-              </a:spcAft>
-            </a:pPr>
-            <a:r>
-              <a:rPr sz="830" b="0">
-                <a:solidFill>
-                  <a:srgbClr val="47517A"/>
-                </a:solidFill>
-                <a:latin typeface="Calibri"/>
-              </a:rPr>
               <a:t>figures deterministic</a:t>
             </a:r>
           </a:p>
@@ -6019,7 +5635,7 @@
       </p:sp>
       <p:sp>
         <p:nvSpPr>
-          <p:cNvPr id="32" name="TextBox 31"/>
+          <p:cNvPr id="28" name="TextBox 27"/>
           <p:cNvSpPr txBox="1"/>
           <p:nvPr/>
         </p:nvSpPr>
@@ -6055,7 +5671,7 @@
                 </a:solidFill>
                 <a:latin typeface="Calibri"/>
               </a:rPr>
-              <a:t>Recommended order: set the policy (1–6) first, then Analyse (7). Confirm (5) fills no fields; allocations only via Apply (6); limits manual. v8: a 🔒 enforced price trigger gates a buy at Analyse (vs a sourced live price); 📡/📝 items never touch a figure.</a:t>
+              <a:t>Recommended order: set the policy (1–2) first, then Analyse (4). The tactical text and documents pass verbatim into one self-contained prompt (5–6) that the AI Model writes from — and that you can copy into any AI model. Every figure is computed deterministically; the AI writes prose only.</a:t>
             </a:r>
           </a:p>
         </p:txBody>

</xml_diff>